<commit_message>
Drop no-op enable_thinking call that only produced warnings
</commit_message>
<xml_diff>
--- a/Videos Pitch/PlainMed-GTC.pptx
+++ b/Videos Pitch/PlainMed-GTC.pptx
@@ -4,6 +4,9 @@
   <p:sldMasterIdLst>
     <p:sldMasterId id="2147483648" r:id="rId1"/>
   </p:sldMasterIdLst>
+  <p:notesMasterIdLst>
+    <p:notesMasterId r:id="rId12"/>
+  </p:notesMasterIdLst>
   <p:sldIdLst>
     <p:sldId id="256" r:id="rId2"/>
     <p:sldId id="257" r:id="rId3"/>
@@ -16,9 +19,6 @@
     <p:sldId id="264" r:id="rId10"/>
     <p:sldId id="265" r:id="rId11"/>
   </p:sldIdLst>
-  <p:notesMasterIdLst>
-    <p:notesMasterId r:id="rId12"/>
-  </p:notesMasterIdLst>
   <p:sldSz cx="12192000" cy="6858000"/>
   <p:notesSz cx="6858000" cy="12192000"/>
   <p:defaultTextStyle>
@@ -113,6 +113,11 @@
       </a:defRPr>
     </a:lvl9pPr>
   </p:defaultTextStyle>
+  <p:extLst>
+    <p:ext uri="{EFAFB233-063F-42B5-8137-9DF3F51BA10A}">
+      <p15:sldGuideLst xmlns:p15="http://schemas.microsoft.com/office/powerpoint/2012/main"/>
+    </p:ext>
+  </p:extLst>
 </p:presentation>
 </file>
 
@@ -138,234 +143,10 @@
           <a:chExt cx="0" cy="0"/>
         </a:xfrm>
       </p:grpSpPr>
-      <p:sp>
-        <p:nvSpPr>
-          <p:cNvPr id="2" name="Header Placeholder 1"/>
-          <p:cNvSpPr>
-            <a:spLocks noGrp="1"/>
-          </p:cNvSpPr>
-          <p:nvPr>
-            <p:ph type="hdr" sz="quarter"/>
-          </p:nvPr>
-        </p:nvSpPr>
-        <p:spPr>
-          <a:xfrm>
-            <a:off x="0" y="0"/>
-            <a:ext cx="2971800" cy="458788"/>
-          </a:xfrm>
-          <a:prstGeom prst="rect">
-            <a:avLst/>
-          </a:prstGeom>
-        </p:spPr>
-        <p:txBody>
-          <a:bodyPr vert="horz" lIns="91440" tIns="45720" rIns="91440" bIns="45720" rtlCol="0"/>
-          <a:lstStyle>
-            <a:lvl1pPr algn="l">
-              <a:defRPr sz="1200"/>
-            </a:lvl1pPr>
-          </a:lstStyle>
-          <a:p>
-            <a:endParaRPr lang="en-US"/>
-          </a:p>
-        </p:txBody>
-      </p:sp>
-      <p:sp>
-        <p:nvSpPr>
-          <p:cNvPr id="3" name="Date Placeholder 2"/>
-          <p:cNvSpPr>
-            <a:spLocks noGrp="1"/>
-          </p:cNvSpPr>
-          <p:nvPr>
-            <p:ph type="dt" idx="1"/>
-          </p:nvPr>
-        </p:nvSpPr>
-        <p:spPr>
-          <a:xfrm>
-            <a:off x="3884613" y="0"/>
-            <a:ext cx="2971800" cy="458788"/>
-          </a:xfrm>
-          <a:prstGeom prst="rect">
-            <a:avLst/>
-          </a:prstGeom>
-        </p:spPr>
-        <p:txBody>
-          <a:bodyPr vert="horz" lIns="91440" tIns="45720" rIns="91440" bIns="45720" rtlCol="0"/>
-          <a:lstStyle>
-            <a:lvl1pPr algn="r">
-              <a:defRPr sz="1200"/>
-            </a:lvl1pPr>
-          </a:lstStyle>
-          <a:p>
-            <a:fld id="{5282F153-3F37-0F45-9E97-73ACFA13230C}" type="datetimeFigureOut">
-              <a:rPr lang="en-US"/>
-              <a:t>7/23/19</a:t>
-            </a:fld>
-            <a:endParaRPr lang="en-US"/>
-          </a:p>
-        </p:txBody>
-      </p:sp>
-      <p:sp>
-        <p:nvSpPr>
-          <p:cNvPr id="4" name="Slide Image Placeholder 3"/>
-          <p:cNvSpPr>
-            <a:spLocks noGrp="1" noRot="1" noChangeAspect="1"/>
-          </p:cNvSpPr>
-          <p:nvPr>
-            <p:ph type="sldImg" idx="2"/>
-          </p:nvPr>
-        </p:nvSpPr>
-        <p:spPr>
-          <a:xfrm>
-            <a:off x="685800" y="1143000"/>
-            <a:ext cx="5486400" cy="3086100"/>
-          </a:xfrm>
-          <a:prstGeom prst="rect">
-            <a:avLst/>
-          </a:prstGeom>
-          <a:noFill/>
-          <a:ln w="12700">
-            <a:solidFill>
-              <a:prstClr val="black"/>
-            </a:solidFill>
-          </a:ln>
-        </p:spPr>
-        <p:txBody>
-          <a:bodyPr vert="horz" lIns="91440" tIns="45720" rIns="91440" bIns="45720" rtlCol="0" anchor="ctr"/>
-          <a:lstStyle/>
-          <a:p>
-            <a:endParaRPr lang="en-US"/>
-          </a:p>
-        </p:txBody>
-      </p:sp>
-      <p:sp>
-        <p:nvSpPr>
-          <p:cNvPr id="5" name="Notes Placeholder 4"/>
-          <p:cNvSpPr>
-            <a:spLocks noGrp="1"/>
-          </p:cNvSpPr>
-          <p:nvPr>
-            <p:ph type="body" sz="quarter" idx="3"/>
-          </p:nvPr>
-        </p:nvSpPr>
-        <p:spPr>
-          <a:xfrm>
-            <a:off x="685800" y="4400550"/>
-            <a:ext cx="5486400" cy="3600450"/>
-          </a:xfrm>
-          <a:prstGeom prst="rect">
-            <a:avLst/>
-          </a:prstGeom>
-        </p:spPr>
-        <p:txBody>
-          <a:bodyPr vert="horz" lIns="91440" tIns="45720" rIns="91440" bIns="45720" rtlCol="0"/>
-          <a:lstStyle/>
-          <a:p>
-            <a:pPr lvl="0"/>
-            <a:r>
-              <a:rPr lang="en-US"/>
-              <a:t>Click to edit Master text styles</a:t>
-            </a:r>
-          </a:p>
-          <a:p>
-            <a:pPr lvl="1"/>
-            <a:r>
-              <a:rPr lang="en-US"/>
-              <a:t>Second level</a:t>
-            </a:r>
-          </a:p>
-          <a:p>
-            <a:pPr lvl="2"/>
-            <a:r>
-              <a:rPr lang="en-US"/>
-              <a:t>Third level</a:t>
-            </a:r>
-          </a:p>
-          <a:p>
-            <a:pPr lvl="3"/>
-            <a:r>
-              <a:rPr lang="en-US"/>
-              <a:t>Fourth level</a:t>
-            </a:r>
-          </a:p>
-          <a:p>
-            <a:pPr lvl="4"/>
-            <a:r>
-              <a:rPr lang="en-US"/>
-              <a:t>Fifth level</a:t>
-            </a:r>
-          </a:p>
-        </p:txBody>
-      </p:sp>
-      <p:sp>
-        <p:nvSpPr>
-          <p:cNvPr id="6" name="Footer Placeholder 5"/>
-          <p:cNvSpPr>
-            <a:spLocks noGrp="1"/>
-          </p:cNvSpPr>
-          <p:nvPr>
-            <p:ph type="ftr" sz="quarter" idx="4"/>
-          </p:nvPr>
-        </p:nvSpPr>
-        <p:spPr>
-          <a:xfrm>
-            <a:off x="0" y="8685213"/>
-            <a:ext cx="2971800" cy="458787"/>
-          </a:xfrm>
-          <a:prstGeom prst="rect">
-            <a:avLst/>
-          </a:prstGeom>
-        </p:spPr>
-        <p:txBody>
-          <a:bodyPr vert="horz" lIns="91440" tIns="45720" rIns="91440" bIns="45720" rtlCol="0" anchor="b"/>
-          <a:lstStyle>
-            <a:lvl1pPr algn="l">
-              <a:defRPr sz="1200"/>
-            </a:lvl1pPr>
-          </a:lstStyle>
-          <a:p>
-            <a:endParaRPr lang="en-US"/>
-          </a:p>
-        </p:txBody>
-      </p:sp>
-      <p:sp>
-        <p:nvSpPr>
-          <p:cNvPr id="7" name="Slide Number Placeholder 6"/>
-          <p:cNvSpPr>
-            <a:spLocks noGrp="1"/>
-          </p:cNvSpPr>
-          <p:nvPr>
-            <p:ph type="sldNum" sz="quarter" idx="5"/>
-          </p:nvPr>
-        </p:nvSpPr>
-        <p:spPr>
-          <a:xfrm>
-            <a:off x="3884613" y="8685213"/>
-            <a:ext cx="2971800" cy="458787"/>
-          </a:xfrm>
-          <a:prstGeom prst="rect">
-            <a:avLst/>
-          </a:prstGeom>
-        </p:spPr>
-        <p:txBody>
-          <a:bodyPr vert="horz" lIns="91440" tIns="45720" rIns="91440" bIns="45720" rtlCol="0" anchor="b"/>
-          <a:lstStyle>
-            <a:lvl1pPr algn="r">
-              <a:defRPr sz="1200"/>
-            </a:lvl1pPr>
-          </a:lstStyle>
-          <a:p>
-            <a:fld id="{CE5E9CC1-C706-0F49-92D6-E571CC5EEA8F}" type="slidenum">
-              <a:rPr lang="en-US"/>
-              <a:t>‹#›</a:t>
-            </a:fld>
-            <a:endParaRPr lang="en-US"/>
-          </a:p>
-        </p:txBody>
-      </p:sp>
     </p:spTree>
     <p:extLst>
       <p:ext uri="{BB962C8B-B14F-4D97-AF65-F5344CB8AC3E}">
-        <p14:creationId xmlns:p14="http://schemas.microsoft.com/office/powerpoint/2010/main" val="1024086991"/>
+        <p14:creationId xmlns:p14="http://schemas.microsoft.com/office/powerpoint/2010/main" val="4209270024"/>
       </p:ext>
     </p:extLst>
   </p:cSld>
@@ -513,7 +294,6 @@
               <a:rPr lang="en-US" dirty="0"/>
               <a:t>Open holding a paper lab report. 'My mother got one of these and Googled her way to a cancer scare over a value that was fine.' Then: watch.</a:t>
             </a:r>
-            <a:endParaRPr lang="en-US" dirty="0"/>
           </a:p>
         </p:txBody>
       </p:sp>
@@ -601,7 +381,6 @@
               <a:rPr lang="en-US" dirty="0"/>
               <a:t>Close on the ask. Do not keep talking after this slide.</a:t>
             </a:r>
-            <a:endParaRPr lang="en-US" dirty="0"/>
           </a:p>
         </p:txBody>
       </p:sp>
@@ -689,7 +468,6 @@
               <a:rPr lang="en-US" dirty="0"/>
               <a:t>Eight minutes with a doctor. A document they cannot read about a body they own.</a:t>
             </a:r>
-            <a:endParaRPr lang="en-US" dirty="0"/>
           </a:p>
         </p:txBody>
       </p:sp>
@@ -777,7 +555,6 @@
               <a:rPr lang="en-US" dirty="0"/>
               <a:t>Live demo goes here: phone, photo, review screen, explanation. Roughly 1.3 seconds for OCR.</a:t>
             </a:r>
-            <a:endParaRPr lang="en-US" dirty="0"/>
           </a:p>
         </p:txBody>
       </p:sp>
@@ -865,7 +642,6 @@
               <a:rPr lang="en-US" dirty="0"/>
               <a:t>Demo moment: feed it a statement with a wrong number and a diagnosis, and show the validator dropping both.</a:t>
             </a:r>
-            <a:endParaRPr lang="en-US" dirty="0"/>
           </a:p>
         </p:txBody>
       </p:sp>
@@ -953,7 +729,6 @@
               <a:rPr lang="en-US" dirty="0"/>
               <a:t>Run scripts/deident_check.py live here. 0.36 seconds, 14 identifier categories withheld, clinical content preserved.</a:t>
             </a:r>
-            <a:endParaRPr lang="en-US" dirty="0"/>
           </a:p>
         </p:txBody>
       </p:sp>
@@ -1041,7 +816,6 @@
               <a:rPr lang="en-US" dirty="0"/>
               <a:t>This is the novel contribution: using a multimodal medical model as an independent verifier rather than as a generator of facts.</a:t>
             </a:r>
-            <a:endParaRPr lang="en-US" dirty="0"/>
           </a:p>
         </p:txBody>
       </p:sp>
@@ -1129,7 +903,6 @@
               <a:rPr lang="en-US" dirty="0"/>
               <a:t>GPU cost will not be the constraint; idle capacity will. Fill in the measured latency and peak VRAM before presenting.</a:t>
             </a:r>
-            <a:endParaRPr lang="en-US" dirty="0"/>
           </a:p>
         </p:txBody>
       </p:sp>
@@ -1217,7 +990,6 @@
               <a:rPr lang="en-US" dirty="0"/>
               <a:t>India is also a cheaper compliance path than the US or EU: no BAA regime, health data has no special category, and cross-border transfer is permissive.</a:t>
             </a:r>
-            <a:endParaRPr lang="en-US" dirty="0"/>
           </a:p>
         </p:txBody>
       </p:sp>
@@ -1305,7 +1077,6 @@
               <a:rPr lang="en-US" dirty="0"/>
               <a:t>Run these live. Terminal printing PASS in under a second beats a bullet point claiming the same thing.</a:t>
             </a:r>
-            <a:endParaRPr lang="en-US" dirty="0"/>
           </a:p>
         </p:txBody>
       </p:sp>
@@ -1378,6 +1149,11 @@
 <file path=ppt/slideMasters/slideMaster1.xml><?xml version="1.0" encoding="utf-8"?>
 <p:sldMaster xmlns:a="http://schemas.openxmlformats.org/drawingml/2006/main" xmlns:r="http://schemas.openxmlformats.org/officeDocument/2006/relationships" xmlns:p="http://schemas.openxmlformats.org/presentationml/2006/main">
   <p:cSld>
+    <p:bg>
+      <p:bgRef idx="1001">
+        <a:schemeClr val="bg1"/>
+      </p:bgRef>
+    </p:bg>
     <p:spTree>
       <p:nvGrpSpPr>
         <p:cNvPr id="1" name=""/>
@@ -1653,13 +1429,14 @@
 </file>
 
 <file path=ppt/slides/slide1.xml><?xml version="1.0" encoding="utf-8"?>
-<p:sld xmlns:a="http://schemas.openxmlformats.org/drawingml/2006/main" xmlns:r="http://schemas.openxmlformats.org/officeDocument/2006/relationships" xmlns:p="http://schemas.openxmlformats.org/presentationml/2006/main">
+<p:sld xmlns:a="http://schemas.openxmlformats.org/drawingml/2006/main" xmlns:r="http://schemas.openxmlformats.org/officeDocument/2006/relationships" xmlns:p="http://schemas.openxmlformats.org/presentationml/2006/main" showMasterSp="0">
   <p:cSld name="Slide 1">
     <p:bg>
       <p:bgPr>
         <a:solidFill>
-          <a:srgbClr val="16324F"/>
+          <a:schemeClr val="bg1"/>
         </a:solidFill>
+        <a:effectLst/>
       </p:bgPr>
     </p:bg>
     <p:spTree>
@@ -1678,60 +1455,6 @@
       </p:grpSpPr>
       <p:sp>
         <p:nvSpPr>
-          <p:cNvPr id="2" name="Shape 0"/>
-          <p:cNvSpPr/>
-          <p:nvPr/>
-        </p:nvSpPr>
-        <p:spPr>
-          <a:xfrm>
-            <a:off x="9052560" y="-1554480"/>
-            <a:ext cx="5120640" cy="5120640"/>
-          </a:xfrm>
-          <a:prstGeom prst="ellipse">
-            <a:avLst/>
-          </a:prstGeom>
-          <a:solidFill>
-            <a:srgbClr val="0F766E">
-              <a:alpha val="24000"/>
-            </a:srgbClr>
-          </a:solidFill>
-          <a:ln w="12700">
-            <a:solidFill>
-              <a:srgbClr val="0F766E"/>
-            </a:solidFill>
-            <a:prstDash val="solid"/>
-          </a:ln>
-        </p:spPr>
-      </p:sp>
-      <p:sp>
-        <p:nvSpPr>
-          <p:cNvPr id="3" name="Shape 1"/>
-          <p:cNvSpPr/>
-          <p:nvPr/>
-        </p:nvSpPr>
-        <p:spPr>
-          <a:xfrm>
-            <a:off x="10424160" y="4206240"/>
-            <a:ext cx="2926080" cy="2926080"/>
-          </a:xfrm>
-          <a:prstGeom prst="ellipse">
-            <a:avLst/>
-          </a:prstGeom>
-          <a:solidFill>
-            <a:srgbClr val="2DD4BF">
-              <a:alpha val="12000"/>
-            </a:srgbClr>
-          </a:solidFill>
-          <a:ln w="12700">
-            <a:solidFill>
-              <a:srgbClr val="2DD4BF"/>
-            </a:solidFill>
-            <a:prstDash val="solid"/>
-          </a:ln>
-        </p:spPr>
-      </p:sp>
-      <p:sp>
-        <p:nvSpPr>
           <p:cNvPr id="4" name="Text 2"/>
           <p:cNvSpPr txBox="1"/>
           <p:nvPr/>
@@ -1751,13 +1474,15 @@
           <a:bodyPr wrap="square" lIns="0" tIns="0" rIns="0" bIns="0" rtlCol="0" anchor="ctr"/>
           <a:lstStyle/>
           <a:p>
-            <a:pPr indent="0" marL="0">
+            <a:pPr marL="0" indent="0">
               <a:buNone/>
             </a:pPr>
             <a:r>
               <a:rPr lang="en-US" sz="6600" b="1" dirty="0">
                 <a:solidFill>
-                  <a:srgbClr val="FFFFFF"/>
+                  <a:schemeClr val="accent1">
+                    <a:lumMod val="50000"/>
+                  </a:schemeClr>
                 </a:solidFill>
                 <a:latin typeface="Cambria" pitchFamily="34" charset="0"/>
                 <a:ea typeface="Cambria" pitchFamily="34" charset="-122"/>
@@ -1765,7 +1490,13 @@
               </a:rPr>
               <a:t>PlainMed</a:t>
             </a:r>
-            <a:endParaRPr lang="en-US" sz="6600" dirty="0"/>
+            <a:endParaRPr lang="en-US" sz="6600" dirty="0">
+              <a:solidFill>
+                <a:schemeClr val="accent1">
+                  <a:lumMod val="50000"/>
+                </a:schemeClr>
+              </a:solidFill>
+            </a:endParaRPr>
           </a:p>
         </p:txBody>
       </p:sp>
@@ -1790,7 +1521,7 @@
           <a:bodyPr wrap="square" lIns="0" tIns="0" rIns="0" bIns="0" rtlCol="0" anchor="ctr"/>
           <a:lstStyle/>
           <a:p>
-            <a:pPr indent="0" marL="0">
+            <a:pPr marL="0" indent="0">
               <a:buNone/>
             </a:pPr>
             <a:r>
@@ -1817,19 +1548,19 @@
         <p:spPr>
           <a:xfrm>
             <a:off x="822960" y="3703320"/>
-            <a:ext cx="7498080" cy="914400"/>
-          </a:xfrm>
-          <a:prstGeom prst="rect">
-            <a:avLst/>
-          </a:prstGeom>
-          <a:noFill/>
-          <a:ln/>
-        </p:spPr>
-        <p:txBody>
-          <a:bodyPr wrap="square" lIns="0" tIns="0" rIns="0" bIns="0" rtlCol="0" anchor="ctr"/>
-          <a:lstStyle/>
-          <a:p>
-            <a:pPr indent="0" marL="0">
+            <a:ext cx="5273040" cy="914400"/>
+          </a:xfrm>
+          <a:prstGeom prst="rect">
+            <a:avLst/>
+          </a:prstGeom>
+          <a:noFill/>
+          <a:ln/>
+        </p:spPr>
+        <p:txBody>
+          <a:bodyPr wrap="square" lIns="0" tIns="0" rIns="0" bIns="0" rtlCol="0" anchor="ctr"/>
+          <a:lstStyle/>
+          <a:p>
+            <a:pPr marL="0" indent="0">
               <a:lnSpc>
                 <a:spcPts val="2200"/>
               </a:lnSpc>
@@ -1838,7 +1569,9 @@
             <a:r>
               <a:rPr lang="en-US" sz="1500" dirty="0">
                 <a:solidFill>
-                  <a:srgbClr val="94A3B8"/>
+                  <a:schemeClr val="accent1">
+                    <a:lumMod val="50000"/>
+                  </a:schemeClr>
                 </a:solidFill>
                 <a:latin typeface="Calibri" pitchFamily="34" charset="0"/>
                 <a:ea typeface="Calibri" pitchFamily="34" charset="-122"/>
@@ -1846,244 +1579,13 @@
               </a:rPr>
               <a:t>A patient photographs a lab report and gets back an explanation where every sentence points at the line that supports it — and the AI never learns who they are.</a:t>
             </a:r>
-            <a:endParaRPr lang="en-US" sz="1500" dirty="0"/>
-          </a:p>
-        </p:txBody>
-      </p:sp>
-      <p:sp>
-        <p:nvSpPr>
-          <p:cNvPr id="7" name="Shape 5"/>
-          <p:cNvSpPr/>
-          <p:nvPr/>
-        </p:nvSpPr>
-        <p:spPr>
-          <a:xfrm>
-            <a:off x="822960" y="4864608"/>
-            <a:ext cx="457200" cy="256032"/>
-          </a:xfrm>
-          <a:prstGeom prst="roundRect">
-            <a:avLst>
-              <a:gd name="adj" fmla="val 25000"/>
-            </a:avLst>
-          </a:prstGeom>
-          <a:solidFill>
-            <a:srgbClr val="2DD4BF"/>
-          </a:solidFill>
-          <a:ln w="6350">
-            <a:solidFill>
-              <a:srgbClr val="2DD4BF"/>
-            </a:solidFill>
-            <a:prstDash val="solid"/>
-          </a:ln>
-        </p:spPr>
-      </p:sp>
-      <p:sp>
-        <p:nvSpPr>
-          <p:cNvPr id="8" name="Text 6"/>
-          <p:cNvSpPr txBox="1"/>
-          <p:nvPr/>
-        </p:nvSpPr>
-        <p:spPr>
-          <a:xfrm>
-            <a:off x="822960" y="4864608"/>
-            <a:ext cx="457200" cy="256032"/>
-          </a:xfrm>
-          <a:prstGeom prst="rect">
-            <a:avLst/>
-          </a:prstGeom>
-          <a:noFill/>
-          <a:ln/>
-        </p:spPr>
-        <p:txBody>
-          <a:bodyPr wrap="square" lIns="0" tIns="0" rIns="0" bIns="0" rtlCol="0" anchor="ctr"/>
-          <a:lstStyle/>
-          <a:p>
-            <a:pPr algn="ctr" indent="0" marL="0">
-              <a:buNone/>
-            </a:pPr>
-            <a:r>
-              <a:rPr lang="en-US" sz="1100" b="1" dirty="0">
-                <a:solidFill>
-                  <a:srgbClr val="16324F"/>
-                </a:solidFill>
-                <a:latin typeface="Calibri" pitchFamily="34" charset="0"/>
-                <a:ea typeface="Calibri" pitchFamily="34" charset="-122"/>
-                <a:cs typeface="Calibri" pitchFamily="34" charset="-120"/>
-              </a:rPr>
-              <a:t>S1</a:t>
-            </a:r>
-            <a:endParaRPr lang="en-US" sz="1100" dirty="0"/>
-          </a:p>
-        </p:txBody>
-      </p:sp>
-      <p:sp>
-        <p:nvSpPr>
-          <p:cNvPr id="9" name="Shape 7"/>
-          <p:cNvSpPr/>
-          <p:nvPr/>
-        </p:nvSpPr>
-        <p:spPr>
-          <a:xfrm>
-            <a:off x="1389888" y="4864608"/>
-            <a:ext cx="457200" cy="256032"/>
-          </a:xfrm>
-          <a:prstGeom prst="roundRect">
-            <a:avLst>
-              <a:gd name="adj" fmla="val 25000"/>
-            </a:avLst>
-          </a:prstGeom>
-          <a:solidFill>
-            <a:srgbClr val="2DD4BF"/>
-          </a:solidFill>
-          <a:ln w="6350">
-            <a:solidFill>
-              <a:srgbClr val="2DD4BF"/>
-            </a:solidFill>
-            <a:prstDash val="solid"/>
-          </a:ln>
-        </p:spPr>
-      </p:sp>
-      <p:sp>
-        <p:nvSpPr>
-          <p:cNvPr id="10" name="Text 8"/>
-          <p:cNvSpPr txBox="1"/>
-          <p:nvPr/>
-        </p:nvSpPr>
-        <p:spPr>
-          <a:xfrm>
-            <a:off x="1389888" y="4864608"/>
-            <a:ext cx="457200" cy="256032"/>
-          </a:xfrm>
-          <a:prstGeom prst="rect">
-            <a:avLst/>
-          </a:prstGeom>
-          <a:noFill/>
-          <a:ln/>
-        </p:spPr>
-        <p:txBody>
-          <a:bodyPr wrap="square" lIns="0" tIns="0" rIns="0" bIns="0" rtlCol="0" anchor="ctr"/>
-          <a:lstStyle/>
-          <a:p>
-            <a:pPr algn="ctr" indent="0" marL="0">
-              <a:buNone/>
-            </a:pPr>
-            <a:r>
-              <a:rPr lang="en-US" sz="1100" b="1" dirty="0">
-                <a:solidFill>
-                  <a:srgbClr val="16324F"/>
-                </a:solidFill>
-                <a:latin typeface="Calibri" pitchFamily="34" charset="0"/>
-                <a:ea typeface="Calibri" pitchFamily="34" charset="-122"/>
-                <a:cs typeface="Calibri" pitchFamily="34" charset="-120"/>
-              </a:rPr>
-              <a:t>S3</a:t>
-            </a:r>
-            <a:endParaRPr lang="en-US" sz="1100" dirty="0"/>
-          </a:p>
-        </p:txBody>
-      </p:sp>
-      <p:sp>
-        <p:nvSpPr>
-          <p:cNvPr id="11" name="Shape 9"/>
-          <p:cNvSpPr/>
-          <p:nvPr/>
-        </p:nvSpPr>
-        <p:spPr>
-          <a:xfrm>
-            <a:off x="1956816" y="4864608"/>
-            <a:ext cx="457200" cy="256032"/>
-          </a:xfrm>
-          <a:prstGeom prst="roundRect">
-            <a:avLst>
-              <a:gd name="adj" fmla="val 25000"/>
-            </a:avLst>
-          </a:prstGeom>
-          <a:solidFill>
-            <a:srgbClr val="2DD4BF"/>
-          </a:solidFill>
-          <a:ln w="6350">
-            <a:solidFill>
-              <a:srgbClr val="2DD4BF"/>
-            </a:solidFill>
-            <a:prstDash val="solid"/>
-          </a:ln>
-        </p:spPr>
-      </p:sp>
-      <p:sp>
-        <p:nvSpPr>
-          <p:cNvPr id="12" name="Text 10"/>
-          <p:cNvSpPr txBox="1"/>
-          <p:nvPr/>
-        </p:nvSpPr>
-        <p:spPr>
-          <a:xfrm>
-            <a:off x="1956816" y="4864608"/>
-            <a:ext cx="457200" cy="256032"/>
-          </a:xfrm>
-          <a:prstGeom prst="rect">
-            <a:avLst/>
-          </a:prstGeom>
-          <a:noFill/>
-          <a:ln/>
-        </p:spPr>
-        <p:txBody>
-          <a:bodyPr wrap="square" lIns="0" tIns="0" rIns="0" bIns="0" rtlCol="0" anchor="ctr"/>
-          <a:lstStyle/>
-          <a:p>
-            <a:pPr algn="ctr" indent="0" marL="0">
-              <a:buNone/>
-            </a:pPr>
-            <a:r>
-              <a:rPr lang="en-US" sz="1100" b="1" dirty="0">
-                <a:solidFill>
-                  <a:srgbClr val="16324F"/>
-                </a:solidFill>
-                <a:latin typeface="Calibri" pitchFamily="34" charset="0"/>
-                <a:ea typeface="Calibri" pitchFamily="34" charset="-122"/>
-                <a:cs typeface="Calibri" pitchFamily="34" charset="-120"/>
-              </a:rPr>
-              <a:t>S7</a:t>
-            </a:r>
-            <a:endParaRPr lang="en-US" sz="1100" dirty="0"/>
-          </a:p>
-        </p:txBody>
-      </p:sp>
-      <p:sp>
-        <p:nvSpPr>
-          <p:cNvPr id="13" name="Text 11"/>
-          <p:cNvSpPr txBox="1"/>
-          <p:nvPr/>
-        </p:nvSpPr>
-        <p:spPr>
-          <a:xfrm>
-            <a:off x="2606040" y="4864608"/>
-            <a:ext cx="4572000" cy="256032"/>
-          </a:xfrm>
-          <a:prstGeom prst="rect">
-            <a:avLst/>
-          </a:prstGeom>
-          <a:noFill/>
-          <a:ln/>
-        </p:spPr>
-        <p:txBody>
-          <a:bodyPr wrap="square" lIns="0" tIns="0" rIns="0" bIns="0" rtlCol="0" anchor="ctr"/>
-          <a:lstStyle/>
-          <a:p>
-            <a:pPr indent="0" marL="0">
-              <a:buNone/>
-            </a:pPr>
-            <a:r>
-              <a:rPr lang="en-US" sz="1200" i="1" dirty="0">
-                <a:solidFill>
-                  <a:srgbClr val="94A3B8"/>
-                </a:solidFill>
-                <a:latin typeface="Calibri" pitchFamily="34" charset="0"/>
-                <a:ea typeface="Calibri" pitchFamily="34" charset="-122"/>
-                <a:cs typeface="Calibri" pitchFamily="34" charset="-120"/>
-              </a:rPr>
-              <a:t>every claim traceable to a line</a:t>
-            </a:r>
-            <a:endParaRPr lang="en-US" sz="1200" dirty="0"/>
+            <a:endParaRPr lang="en-US" sz="1500" dirty="0">
+              <a:solidFill>
+                <a:schemeClr val="accent1">
+                  <a:lumMod val="50000"/>
+                </a:schemeClr>
+              </a:solidFill>
+            </a:endParaRPr>
           </a:p>
         </p:txBody>
       </p:sp>
@@ -2108,7 +1610,7 @@
           <a:bodyPr wrap="square" lIns="0" tIns="0" rIns="0" bIns="0" rtlCol="0" anchor="ctr"/>
           <a:lstStyle/>
           <a:p>
-            <a:pPr indent="0" marL="0">
+            <a:pPr marL="0" indent="0">
               <a:buNone/>
             </a:pPr>
             <a:r>
@@ -2126,6 +1628,66 @@
           </a:p>
         </p:txBody>
       </p:sp>
+      <p:pic>
+        <p:nvPicPr>
+          <p:cNvPr id="16" name="Picture 15">
+            <a:extLst>
+              <a:ext uri="{FF2B5EF4-FFF2-40B4-BE49-F238E27FC236}">
+                <a16:creationId xmlns:a16="http://schemas.microsoft.com/office/drawing/2014/main" id="{4609F4BC-413E-0F2E-4B9D-6103CBF5449D}"/>
+              </a:ext>
+            </a:extLst>
+          </p:cNvPr>
+          <p:cNvPicPr>
+            <a:picLocks noChangeAspect="1"/>
+          </p:cNvPicPr>
+          <p:nvPr/>
+        </p:nvPicPr>
+        <p:blipFill>
+          <a:blip r:embed="rId3"/>
+          <a:stretch>
+            <a:fillRect/>
+          </a:stretch>
+        </p:blipFill>
+        <p:spPr>
+          <a:xfrm>
+            <a:off x="501114" y="341180"/>
+            <a:ext cx="1545063" cy="1545063"/>
+          </a:xfrm>
+          <a:prstGeom prst="rect">
+            <a:avLst/>
+          </a:prstGeom>
+        </p:spPr>
+      </p:pic>
+      <p:pic>
+        <p:nvPicPr>
+          <p:cNvPr id="20" name="Image 0" descr="preencoded.png">
+            <a:extLst>
+              <a:ext uri="{FF2B5EF4-FFF2-40B4-BE49-F238E27FC236}">
+                <a16:creationId xmlns:a16="http://schemas.microsoft.com/office/drawing/2014/main" id="{C47EBD6D-87EF-6C8D-265C-9C04F98C1FFC}"/>
+              </a:ext>
+            </a:extLst>
+          </p:cNvPr>
+          <p:cNvPicPr>
+            <a:picLocks noChangeAspect="1"/>
+          </p:cNvPicPr>
+          <p:nvPr/>
+        </p:nvPicPr>
+        <p:blipFill>
+          <a:blip r:embed="rId4"/>
+          <a:stretch>
+            <a:fillRect/>
+          </a:stretch>
+        </p:blipFill>
+        <p:spPr>
+          <a:xfrm>
+            <a:off x="6096000" y="2146652"/>
+            <a:ext cx="5804795" cy="3204777"/>
+          </a:xfrm>
+          <a:prstGeom prst="rect">
+            <a:avLst/>
+          </a:prstGeom>
+        </p:spPr>
+      </p:pic>
     </p:spTree>
   </p:cSld>
   <p:clrMapOvr>
@@ -2142,6 +1704,7 @@
         <a:solidFill>
           <a:srgbClr val="16324F"/>
         </a:solidFill>
+        <a:effectLst/>
       </p:bgPr>
     </p:bg>
     <p:spTree>
@@ -2184,6 +1747,13 @@
             <a:prstDash val="solid"/>
           </a:ln>
         </p:spPr>
+        <p:txBody>
+          <a:bodyPr/>
+          <a:lstStyle/>
+          <a:p>
+            <a:endParaRPr lang="en-BE"/>
+          </a:p>
+        </p:txBody>
       </p:sp>
       <p:sp>
         <p:nvSpPr>
@@ -2206,7 +1776,7 @@
           <a:bodyPr wrap="square" lIns="0" tIns="0" rIns="0" bIns="0" rtlCol="0" anchor="ctr"/>
           <a:lstStyle/>
           <a:p>
-            <a:pPr indent="0" marL="0">
+            <a:pPr marL="0" indent="0">
               <a:lnSpc>
                 <a:spcPts val="5000"/>
               </a:lnSpc>
@@ -2226,7 +1796,7 @@
             <a:endParaRPr lang="en-US" sz="4200" dirty="0"/>
           </a:p>
           <a:p>
-            <a:pPr indent="0" marL="0">
+            <a:pPr marL="0" indent="0">
               <a:lnSpc>
                 <a:spcPts val="5000"/>
               </a:lnSpc>
@@ -2268,7 +1838,7 @@
           <a:bodyPr wrap="square" lIns="0" tIns="0" rIns="0" bIns="0" rtlCol="0" anchor="ctr"/>
           <a:lstStyle/>
           <a:p>
-            <a:pPr indent="0" marL="0">
+            <a:pPr marL="0" indent="0">
               <a:buNone/>
             </a:pPr>
             <a:r>
@@ -2307,7 +1877,7 @@
           <a:bodyPr wrap="square" lIns="0" tIns="0" rIns="0" bIns="0" rtlCol="0" anchor="ctr"/>
           <a:lstStyle/>
           <a:p>
-            <a:pPr indent="0" marL="0">
+            <a:pPr marL="0" indent="0">
               <a:buNone/>
             </a:pPr>
             <a:r>
@@ -2346,7 +1916,7 @@
           <a:bodyPr wrap="square" lIns="0" tIns="0" rIns="0" bIns="0" rtlCol="0" anchor="ctr"/>
           <a:lstStyle/>
           <a:p>
-            <a:pPr indent="0" marL="0">
+            <a:pPr marL="0" indent="0">
               <a:buNone/>
             </a:pPr>
             <a:r>
@@ -2385,7 +1955,7 @@
           <a:bodyPr wrap="square" lIns="0" tIns="0" rIns="0" bIns="0" rtlCol="0" anchor="ctr"/>
           <a:lstStyle/>
           <a:p>
-            <a:pPr indent="0" marL="0">
+            <a:pPr marL="0" indent="0">
               <a:buNone/>
             </a:pPr>
             <a:r>
@@ -2424,7 +1994,7 @@
           <a:bodyPr wrap="square" lIns="0" tIns="0" rIns="0" bIns="0" rtlCol="0" anchor="ctr"/>
           <a:lstStyle/>
           <a:p>
-            <a:pPr indent="0" marL="0">
+            <a:pPr marL="0" indent="0">
               <a:buNone/>
             </a:pPr>
             <a:r>
@@ -2463,7 +2033,7 @@
           <a:bodyPr wrap="square" lIns="0" tIns="0" rIns="0" bIns="0" rtlCol="0" anchor="ctr"/>
           <a:lstStyle/>
           <a:p>
-            <a:pPr indent="0" marL="0">
+            <a:pPr marL="0" indent="0">
               <a:buNone/>
             </a:pPr>
             <a:r>
@@ -2502,7 +2072,7 @@
           <a:bodyPr wrap="square" lIns="0" tIns="0" rIns="0" bIns="0" rtlCol="0" anchor="ctr"/>
           <a:lstStyle/>
           <a:p>
-            <a:pPr indent="0" marL="0">
+            <a:pPr marL="0" indent="0">
               <a:buNone/>
             </a:pPr>
             <a:r>
@@ -2517,204 +2087,6 @@
               <a:t>GPU access to move from validated architecture to measured performance</a:t>
             </a:r>
             <a:endParaRPr lang="en-US" sz="1300" dirty="0"/>
-          </a:p>
-        </p:txBody>
-      </p:sp>
-      <p:sp>
-        <p:nvSpPr>
-          <p:cNvPr id="11" name="Shape 9"/>
-          <p:cNvSpPr/>
-          <p:nvPr/>
-        </p:nvSpPr>
-        <p:spPr>
-          <a:xfrm>
-            <a:off x="822960" y="5943600"/>
-            <a:ext cx="457200" cy="256032"/>
-          </a:xfrm>
-          <a:prstGeom prst="roundRect">
-            <a:avLst>
-              <a:gd name="adj" fmla="val 25000"/>
-            </a:avLst>
-          </a:prstGeom>
-          <a:solidFill>
-            <a:srgbClr val="2DD4BF"/>
-          </a:solidFill>
-          <a:ln w="6350">
-            <a:solidFill>
-              <a:srgbClr val="2DD4BF"/>
-            </a:solidFill>
-            <a:prstDash val="solid"/>
-          </a:ln>
-        </p:spPr>
-      </p:sp>
-      <p:sp>
-        <p:nvSpPr>
-          <p:cNvPr id="12" name="Text 10"/>
-          <p:cNvSpPr txBox="1"/>
-          <p:nvPr/>
-        </p:nvSpPr>
-        <p:spPr>
-          <a:xfrm>
-            <a:off x="822960" y="5943600"/>
-            <a:ext cx="457200" cy="256032"/>
-          </a:xfrm>
-          <a:prstGeom prst="rect">
-            <a:avLst/>
-          </a:prstGeom>
-          <a:noFill/>
-          <a:ln/>
-        </p:spPr>
-        <p:txBody>
-          <a:bodyPr wrap="square" lIns="0" tIns="0" rIns="0" bIns="0" rtlCol="0" anchor="ctr"/>
-          <a:lstStyle/>
-          <a:p>
-            <a:pPr algn="ctr" indent="0" marL="0">
-              <a:buNone/>
-            </a:pPr>
-            <a:r>
-              <a:rPr lang="en-US" sz="1100" b="1" dirty="0">
-                <a:solidFill>
-                  <a:srgbClr val="16324F"/>
-                </a:solidFill>
-                <a:latin typeface="Calibri" pitchFamily="34" charset="0"/>
-                <a:ea typeface="Calibri" pitchFamily="34" charset="-122"/>
-                <a:cs typeface="Calibri" pitchFamily="34" charset="-120"/>
-              </a:rPr>
-              <a:t>S1</a:t>
-            </a:r>
-            <a:endParaRPr lang="en-US" sz="1100" dirty="0"/>
-          </a:p>
-        </p:txBody>
-      </p:sp>
-      <p:sp>
-        <p:nvSpPr>
-          <p:cNvPr id="13" name="Shape 11"/>
-          <p:cNvSpPr/>
-          <p:nvPr/>
-        </p:nvSpPr>
-        <p:spPr>
-          <a:xfrm>
-            <a:off x="1389888" y="5943600"/>
-            <a:ext cx="457200" cy="256032"/>
-          </a:xfrm>
-          <a:prstGeom prst="roundRect">
-            <a:avLst>
-              <a:gd name="adj" fmla="val 25000"/>
-            </a:avLst>
-          </a:prstGeom>
-          <a:solidFill>
-            <a:srgbClr val="2DD4BF"/>
-          </a:solidFill>
-          <a:ln w="6350">
-            <a:solidFill>
-              <a:srgbClr val="2DD4BF"/>
-            </a:solidFill>
-            <a:prstDash val="solid"/>
-          </a:ln>
-        </p:spPr>
-      </p:sp>
-      <p:sp>
-        <p:nvSpPr>
-          <p:cNvPr id="14" name="Text 12"/>
-          <p:cNvSpPr txBox="1"/>
-          <p:nvPr/>
-        </p:nvSpPr>
-        <p:spPr>
-          <a:xfrm>
-            <a:off x="1389888" y="5943600"/>
-            <a:ext cx="457200" cy="256032"/>
-          </a:xfrm>
-          <a:prstGeom prst="rect">
-            <a:avLst/>
-          </a:prstGeom>
-          <a:noFill/>
-          <a:ln/>
-        </p:spPr>
-        <p:txBody>
-          <a:bodyPr wrap="square" lIns="0" tIns="0" rIns="0" bIns="0" rtlCol="0" anchor="ctr"/>
-          <a:lstStyle/>
-          <a:p>
-            <a:pPr algn="ctr" indent="0" marL="0">
-              <a:buNone/>
-            </a:pPr>
-            <a:r>
-              <a:rPr lang="en-US" sz="1100" b="1" dirty="0">
-                <a:solidFill>
-                  <a:srgbClr val="16324F"/>
-                </a:solidFill>
-                <a:latin typeface="Calibri" pitchFamily="34" charset="0"/>
-                <a:ea typeface="Calibri" pitchFamily="34" charset="-122"/>
-                <a:cs typeface="Calibri" pitchFamily="34" charset="-120"/>
-              </a:rPr>
-              <a:t>S3</a:t>
-            </a:r>
-            <a:endParaRPr lang="en-US" sz="1100" dirty="0"/>
-          </a:p>
-        </p:txBody>
-      </p:sp>
-      <p:sp>
-        <p:nvSpPr>
-          <p:cNvPr id="15" name="Shape 13"/>
-          <p:cNvSpPr/>
-          <p:nvPr/>
-        </p:nvSpPr>
-        <p:spPr>
-          <a:xfrm>
-            <a:off x="1956816" y="5943600"/>
-            <a:ext cx="457200" cy="256032"/>
-          </a:xfrm>
-          <a:prstGeom prst="roundRect">
-            <a:avLst>
-              <a:gd name="adj" fmla="val 25000"/>
-            </a:avLst>
-          </a:prstGeom>
-          <a:solidFill>
-            <a:srgbClr val="2DD4BF"/>
-          </a:solidFill>
-          <a:ln w="6350">
-            <a:solidFill>
-              <a:srgbClr val="2DD4BF"/>
-            </a:solidFill>
-            <a:prstDash val="solid"/>
-          </a:ln>
-        </p:spPr>
-      </p:sp>
-      <p:sp>
-        <p:nvSpPr>
-          <p:cNvPr id="16" name="Text 14"/>
-          <p:cNvSpPr txBox="1"/>
-          <p:nvPr/>
-        </p:nvSpPr>
-        <p:spPr>
-          <a:xfrm>
-            <a:off x="1956816" y="5943600"/>
-            <a:ext cx="457200" cy="256032"/>
-          </a:xfrm>
-          <a:prstGeom prst="rect">
-            <a:avLst/>
-          </a:prstGeom>
-          <a:noFill/>
-          <a:ln/>
-        </p:spPr>
-        <p:txBody>
-          <a:bodyPr wrap="square" lIns="0" tIns="0" rIns="0" bIns="0" rtlCol="0" anchor="ctr"/>
-          <a:lstStyle/>
-          <a:p>
-            <a:pPr algn="ctr" indent="0" marL="0">
-              <a:buNone/>
-            </a:pPr>
-            <a:r>
-              <a:rPr lang="en-US" sz="1100" b="1" dirty="0">
-                <a:solidFill>
-                  <a:srgbClr val="16324F"/>
-                </a:solidFill>
-                <a:latin typeface="Calibri" pitchFamily="34" charset="0"/>
-                <a:ea typeface="Calibri" pitchFamily="34" charset="-122"/>
-                <a:cs typeface="Calibri" pitchFamily="34" charset="-120"/>
-              </a:rPr>
-              <a:t>S7</a:t>
-            </a:r>
-            <a:endParaRPr lang="en-US" sz="1100" dirty="0"/>
           </a:p>
         </p:txBody>
       </p:sp>
@@ -2739,7 +2111,7 @@
           <a:bodyPr wrap="square" lIns="0" tIns="0" rIns="0" bIns="0" rtlCol="0" anchor="ctr"/>
           <a:lstStyle/>
           <a:p>
-            <a:pPr indent="0" marL="0">
+            <a:pPr marL="0" indent="0">
               <a:buNone/>
             </a:pPr>
             <a:r>
@@ -2773,6 +2145,7 @@
         <a:solidFill>
           <a:srgbClr val="F8FAFC"/>
         </a:solidFill>
+        <a:effectLst/>
       </p:bgPr>
     </p:bg>
     <p:spTree>
@@ -2810,11 +2183,11 @@
           <a:bodyPr wrap="square" lIns="0" tIns="0" rIns="0" bIns="0" rtlCol="0" anchor="ctr"/>
           <a:lstStyle/>
           <a:p>
-            <a:pPr indent="0" marL="0">
-              <a:buNone/>
-            </a:pPr>
-            <a:r>
-              <a:rPr lang="en-US" sz="1300" b="1" spc="200" kern="0" dirty="0">
+            <a:pPr marL="0" indent="0">
+              <a:buNone/>
+            </a:pPr>
+            <a:r>
+              <a:rPr lang="en-US" sz="1300" b="1" kern="0" spc="200" dirty="0">
                 <a:solidFill>
                   <a:srgbClr val="0F766E"/>
                 </a:solidFill>
@@ -2849,7 +2222,7 @@
           <a:bodyPr wrap="square" lIns="0" tIns="0" rIns="0" bIns="0" rtlCol="0" anchor="ctr"/>
           <a:lstStyle/>
           <a:p>
-            <a:pPr indent="0" marL="0">
+            <a:pPr marL="0" indent="0">
               <a:buNone/>
             </a:pPr>
             <a:r>
@@ -2893,13 +2266,20 @@
             <a:prstDash val="solid"/>
           </a:ln>
           <a:effectLst>
-            <a:outerShdw sx="100000" sy="100000" kx="0" ky="0" algn="bl" rotWithShape="0" blurRad="177800" dist="25400" dir="5400000">
+            <a:outerShdw blurRad="177800" dist="25400" dir="5400000" algn="bl" rotWithShape="0">
               <a:srgbClr val="0A1622">
                 <a:alpha val="16000"/>
               </a:srgbClr>
             </a:outerShdw>
           </a:effectLst>
         </p:spPr>
+        <p:txBody>
+          <a:bodyPr/>
+          <a:lstStyle/>
+          <a:p>
+            <a:endParaRPr lang="en-BE"/>
+          </a:p>
+        </p:txBody>
       </p:sp>
       <p:sp>
         <p:nvSpPr>
@@ -2925,6 +2305,13 @@
             <a:prstDash val="solid"/>
           </a:ln>
         </p:spPr>
+        <p:txBody>
+          <a:bodyPr/>
+          <a:lstStyle/>
+          <a:p>
+            <a:endParaRPr lang="en-BE"/>
+          </a:p>
+        </p:txBody>
       </p:sp>
       <p:sp>
         <p:nvSpPr>
@@ -2947,7 +2334,7 @@
           <a:bodyPr wrap="square" lIns="0" tIns="0" rIns="0" bIns="0" rtlCol="0" anchor="ctr"/>
           <a:lstStyle/>
           <a:p>
-            <a:pPr algn="ctr" indent="0" marL="0">
+            <a:pPr marL="0" indent="0" algn="ctr">
               <a:buNone/>
             </a:pPr>
             <a:r>
@@ -2986,7 +2373,7 @@
           <a:bodyPr wrap="square" lIns="0" tIns="0" rIns="0" bIns="0" rtlCol="0" anchor="ctr"/>
           <a:lstStyle/>
           <a:p>
-            <a:pPr indent="0" marL="0">
+            <a:pPr marL="0" indent="0">
               <a:buNone/>
             </a:pPr>
             <a:r>
@@ -3025,7 +2412,7 @@
           <a:bodyPr wrap="square" lIns="0" tIns="0" rIns="0" bIns="0" rtlCol="0" anchor="ctr"/>
           <a:lstStyle/>
           <a:p>
-            <a:pPr indent="0" marL="0">
+            <a:pPr marL="0" indent="0">
               <a:lnSpc>
                 <a:spcPts val="1900"/>
               </a:lnSpc>
@@ -3072,13 +2459,20 @@
             <a:prstDash val="solid"/>
           </a:ln>
           <a:effectLst>
-            <a:outerShdw sx="100000" sy="100000" kx="0" ky="0" algn="bl" rotWithShape="0" blurRad="177800" dist="25400" dir="5400000">
+            <a:outerShdw blurRad="177800" dist="25400" dir="5400000" algn="bl" rotWithShape="0">
               <a:srgbClr val="0A1622">
                 <a:alpha val="16000"/>
               </a:srgbClr>
             </a:outerShdw>
           </a:effectLst>
         </p:spPr>
+        <p:txBody>
+          <a:bodyPr/>
+          <a:lstStyle/>
+          <a:p>
+            <a:endParaRPr lang="en-BE"/>
+          </a:p>
+        </p:txBody>
       </p:sp>
       <p:sp>
         <p:nvSpPr>
@@ -3104,6 +2498,13 @@
             <a:prstDash val="solid"/>
           </a:ln>
         </p:spPr>
+        <p:txBody>
+          <a:bodyPr/>
+          <a:lstStyle/>
+          <a:p>
+            <a:endParaRPr lang="en-BE"/>
+          </a:p>
+        </p:txBody>
       </p:sp>
       <p:sp>
         <p:nvSpPr>
@@ -3126,7 +2527,7 @@
           <a:bodyPr wrap="square" lIns="0" tIns="0" rIns="0" bIns="0" rtlCol="0" anchor="ctr"/>
           <a:lstStyle/>
           <a:p>
-            <a:pPr algn="ctr" indent="0" marL="0">
+            <a:pPr marL="0" indent="0" algn="ctr">
               <a:buNone/>
             </a:pPr>
             <a:r>
@@ -3165,7 +2566,7 @@
           <a:bodyPr wrap="square" lIns="0" tIns="0" rIns="0" bIns="0" rtlCol="0" anchor="ctr"/>
           <a:lstStyle/>
           <a:p>
-            <a:pPr indent="0" marL="0">
+            <a:pPr marL="0" indent="0">
               <a:buNone/>
             </a:pPr>
             <a:r>
@@ -3204,7 +2605,7 @@
           <a:bodyPr wrap="square" lIns="0" tIns="0" rIns="0" bIns="0" rtlCol="0" anchor="ctr"/>
           <a:lstStyle/>
           <a:p>
-            <a:pPr indent="0" marL="0">
+            <a:pPr marL="0" indent="0">
               <a:lnSpc>
                 <a:spcPts val="1900"/>
               </a:lnSpc>
@@ -3242,7 +2643,9 @@
             </a:avLst>
           </a:prstGeom>
           <a:solidFill>
-            <a:srgbClr val="16324F"/>
+            <a:schemeClr val="accent1">
+              <a:lumMod val="75000"/>
+            </a:schemeClr>
           </a:solidFill>
           <a:ln w="12700">
             <a:solidFill>
@@ -3251,13 +2654,20 @@
             <a:prstDash val="solid"/>
           </a:ln>
           <a:effectLst>
-            <a:outerShdw sx="100000" sy="100000" kx="0" ky="0" algn="bl" rotWithShape="0" blurRad="177800" dist="25400" dir="5400000">
+            <a:outerShdw blurRad="177800" dist="25400" dir="5400000" algn="bl" rotWithShape="0">
               <a:srgbClr val="0A1622">
                 <a:alpha val="16000"/>
               </a:srgbClr>
             </a:outerShdw>
           </a:effectLst>
         </p:spPr>
+        <p:txBody>
+          <a:bodyPr/>
+          <a:lstStyle/>
+          <a:p>
+            <a:endParaRPr lang="en-BE"/>
+          </a:p>
+        </p:txBody>
       </p:sp>
       <p:sp>
         <p:nvSpPr>
@@ -3280,7 +2690,7 @@
           <a:bodyPr wrap="square" lIns="0" tIns="0" rIns="0" bIns="0" rtlCol="0" anchor="ctr"/>
           <a:lstStyle/>
           <a:p>
-            <a:pPr indent="0" marL="0">
+            <a:pPr marL="0" indent="0">
               <a:lnSpc>
                 <a:spcPts val="2100"/>
               </a:lnSpc>
@@ -3322,7 +2732,7 @@
           <a:bodyPr wrap="square" lIns="0" tIns="0" rIns="0" bIns="0" rtlCol="0" anchor="ctr"/>
           <a:lstStyle/>
           <a:p>
-            <a:pPr indent="0" marL="0">
+            <a:pPr marL="0" indent="0">
               <a:buNone/>
             </a:pPr>
             <a:r>
@@ -3361,7 +2771,7 @@
           <a:bodyPr wrap="square" lIns="0" tIns="0" rIns="0" bIns="0" rtlCol="0" anchor="ctr"/>
           <a:lstStyle/>
           <a:p>
-            <a:pPr indent="0" marL="0">
+            <a:pPr marL="0" indent="0">
               <a:lnSpc>
                 <a:spcPts val="1800"/>
               </a:lnSpc>
@@ -3403,7 +2813,7 @@
           <a:bodyPr wrap="square" lIns="0" tIns="0" rIns="0" bIns="0" rtlCol="0" anchor="ctr"/>
           <a:lstStyle/>
           <a:p>
-            <a:pPr indent="0" marL="0">
+            <a:pPr marL="0" indent="0">
               <a:buNone/>
             </a:pPr>
             <a:r>
@@ -3437,6 +2847,7 @@
         <a:solidFill>
           <a:srgbClr val="F8FAFC"/>
         </a:solidFill>
+        <a:effectLst/>
       </p:bgPr>
     </p:bg>
     <p:spTree>
@@ -3474,11 +2885,11 @@
           <a:bodyPr wrap="square" lIns="0" tIns="0" rIns="0" bIns="0" rtlCol="0" anchor="ctr"/>
           <a:lstStyle/>
           <a:p>
-            <a:pPr indent="0" marL="0">
-              <a:buNone/>
-            </a:pPr>
-            <a:r>
-              <a:rPr lang="en-US" sz="1300" b="1" spc="200" kern="0" dirty="0">
+            <a:pPr marL="0" indent="0">
+              <a:buNone/>
+            </a:pPr>
+            <a:r>
+              <a:rPr lang="en-US" sz="1300" b="1" kern="0" spc="200" dirty="0">
                 <a:solidFill>
                   <a:srgbClr val="0F766E"/>
                 </a:solidFill>
@@ -3513,7 +2924,7 @@
           <a:bodyPr wrap="square" lIns="0" tIns="0" rIns="0" bIns="0" rtlCol="0" anchor="ctr"/>
           <a:lstStyle/>
           <a:p>
-            <a:pPr indent="0" marL="0">
+            <a:pPr marL="0" indent="0">
               <a:buNone/>
             </a:pPr>
             <a:r>
@@ -3557,13 +2968,20 @@
             <a:prstDash val="solid"/>
           </a:ln>
           <a:effectLst>
-            <a:outerShdw sx="100000" sy="100000" kx="0" ky="0" algn="bl" rotWithShape="0" blurRad="177800" dist="25400" dir="5400000">
+            <a:outerShdw blurRad="177800" dist="25400" dir="5400000" algn="bl" rotWithShape="0">
               <a:srgbClr val="0A1622">
                 <a:alpha val="16000"/>
               </a:srgbClr>
             </a:outerShdw>
           </a:effectLst>
         </p:spPr>
+        <p:txBody>
+          <a:bodyPr/>
+          <a:lstStyle/>
+          <a:p>
+            <a:endParaRPr lang="en-BE"/>
+          </a:p>
+        </p:txBody>
       </p:sp>
       <p:sp>
         <p:nvSpPr>
@@ -3589,6 +3007,13 @@
             <a:prstDash val="solid"/>
           </a:ln>
         </p:spPr>
+        <p:txBody>
+          <a:bodyPr/>
+          <a:lstStyle/>
+          <a:p>
+            <a:endParaRPr lang="en-BE"/>
+          </a:p>
+        </p:txBody>
       </p:sp>
       <p:sp>
         <p:nvSpPr>
@@ -3611,7 +3036,7 @@
           <a:bodyPr wrap="square" lIns="0" tIns="0" rIns="0" bIns="0" rtlCol="0" anchor="ctr"/>
           <a:lstStyle/>
           <a:p>
-            <a:pPr algn="ctr" indent="0" marL="0">
+            <a:pPr marL="0" indent="0" algn="ctr">
               <a:buNone/>
             </a:pPr>
             <a:r>
@@ -3650,7 +3075,7 @@
           <a:bodyPr wrap="square" lIns="0" tIns="0" rIns="0" bIns="0" rtlCol="0" anchor="ctr"/>
           <a:lstStyle/>
           <a:p>
-            <a:pPr indent="0" marL="0">
+            <a:pPr marL="0" indent="0">
               <a:buNone/>
             </a:pPr>
             <a:r>
@@ -3689,7 +3114,7 @@
           <a:bodyPr wrap="square" lIns="0" tIns="0" rIns="0" bIns="0" rtlCol="0" anchor="ctr"/>
           <a:lstStyle/>
           <a:p>
-            <a:pPr indent="0" marL="0">
+            <a:pPr marL="0" indent="0">
               <a:lnSpc>
                 <a:spcPts val="1700"/>
               </a:lnSpc>
@@ -3709,7 +3134,7 @@
             <a:endParaRPr lang="en-US" sz="1250" dirty="0"/>
           </a:p>
           <a:p>
-            <a:pPr indent="0" marL="0">
+            <a:pPr marL="0" indent="0">
               <a:lnSpc>
                 <a:spcPts val="1700"/>
               </a:lnSpc>
@@ -3751,7 +3176,7 @@
           <a:bodyPr wrap="square" lIns="0" tIns="0" rIns="0" bIns="0" rtlCol="0" anchor="ctr"/>
           <a:lstStyle/>
           <a:p>
-            <a:pPr algn="ctr" indent="0" marL="0">
+            <a:pPr marL="0" indent="0" algn="ctr">
               <a:buNone/>
             </a:pPr>
             <a:r>
@@ -3795,13 +3220,20 @@
             <a:prstDash val="solid"/>
           </a:ln>
           <a:effectLst>
-            <a:outerShdw sx="100000" sy="100000" kx="0" ky="0" algn="bl" rotWithShape="0" blurRad="177800" dist="25400" dir="5400000">
+            <a:outerShdw blurRad="177800" dist="25400" dir="5400000" algn="bl" rotWithShape="0">
               <a:srgbClr val="0A1622">
                 <a:alpha val="16000"/>
               </a:srgbClr>
             </a:outerShdw>
           </a:effectLst>
         </p:spPr>
+        <p:txBody>
+          <a:bodyPr/>
+          <a:lstStyle/>
+          <a:p>
+            <a:endParaRPr lang="en-BE"/>
+          </a:p>
+        </p:txBody>
       </p:sp>
       <p:sp>
         <p:nvSpPr>
@@ -3827,6 +3259,13 @@
             <a:prstDash val="solid"/>
           </a:ln>
         </p:spPr>
+        <p:txBody>
+          <a:bodyPr/>
+          <a:lstStyle/>
+          <a:p>
+            <a:endParaRPr lang="en-BE"/>
+          </a:p>
+        </p:txBody>
       </p:sp>
       <p:sp>
         <p:nvSpPr>
@@ -3849,7 +3288,7 @@
           <a:bodyPr wrap="square" lIns="0" tIns="0" rIns="0" bIns="0" rtlCol="0" anchor="ctr"/>
           <a:lstStyle/>
           <a:p>
-            <a:pPr algn="ctr" indent="0" marL="0">
+            <a:pPr marL="0" indent="0" algn="ctr">
               <a:buNone/>
             </a:pPr>
             <a:r>
@@ -3888,7 +3327,7 @@
           <a:bodyPr wrap="square" lIns="0" tIns="0" rIns="0" bIns="0" rtlCol="0" anchor="ctr"/>
           <a:lstStyle/>
           <a:p>
-            <a:pPr indent="0" marL="0">
+            <a:pPr marL="0" indent="0">
               <a:buNone/>
             </a:pPr>
             <a:r>
@@ -3927,7 +3366,7 @@
           <a:bodyPr wrap="square" lIns="0" tIns="0" rIns="0" bIns="0" rtlCol="0" anchor="ctr"/>
           <a:lstStyle/>
           <a:p>
-            <a:pPr indent="0" marL="0">
+            <a:pPr marL="0" indent="0">
               <a:lnSpc>
                 <a:spcPts val="1700"/>
               </a:lnSpc>
@@ -3947,7 +3386,7 @@
             <a:endParaRPr lang="en-US" sz="1250" dirty="0"/>
           </a:p>
           <a:p>
-            <a:pPr indent="0" marL="0">
+            <a:pPr marL="0" indent="0">
               <a:lnSpc>
                 <a:spcPts val="1700"/>
               </a:lnSpc>
@@ -3989,7 +3428,7 @@
           <a:bodyPr wrap="square" lIns="0" tIns="0" rIns="0" bIns="0" rtlCol="0" anchor="ctr"/>
           <a:lstStyle/>
           <a:p>
-            <a:pPr algn="ctr" indent="0" marL="0">
+            <a:pPr marL="0" indent="0" algn="ctr">
               <a:buNone/>
             </a:pPr>
             <a:r>
@@ -4033,13 +3472,20 @@
             <a:prstDash val="solid"/>
           </a:ln>
           <a:effectLst>
-            <a:outerShdw sx="100000" sy="100000" kx="0" ky="0" algn="bl" rotWithShape="0" blurRad="177800" dist="25400" dir="5400000">
+            <a:outerShdw blurRad="177800" dist="25400" dir="5400000" algn="bl" rotWithShape="0">
               <a:srgbClr val="0A1622">
                 <a:alpha val="16000"/>
               </a:srgbClr>
             </a:outerShdw>
           </a:effectLst>
         </p:spPr>
+        <p:txBody>
+          <a:bodyPr/>
+          <a:lstStyle/>
+          <a:p>
+            <a:endParaRPr lang="en-BE"/>
+          </a:p>
+        </p:txBody>
       </p:sp>
       <p:sp>
         <p:nvSpPr>
@@ -4065,6 +3511,13 @@
             <a:prstDash val="solid"/>
           </a:ln>
         </p:spPr>
+        <p:txBody>
+          <a:bodyPr/>
+          <a:lstStyle/>
+          <a:p>
+            <a:endParaRPr lang="en-BE"/>
+          </a:p>
+        </p:txBody>
       </p:sp>
       <p:sp>
         <p:nvSpPr>
@@ -4087,7 +3540,7 @@
           <a:bodyPr wrap="square" lIns="0" tIns="0" rIns="0" bIns="0" rtlCol="0" anchor="ctr"/>
           <a:lstStyle/>
           <a:p>
-            <a:pPr algn="ctr" indent="0" marL="0">
+            <a:pPr marL="0" indent="0" algn="ctr">
               <a:buNone/>
             </a:pPr>
             <a:r>
@@ -4126,7 +3579,7 @@
           <a:bodyPr wrap="square" lIns="0" tIns="0" rIns="0" bIns="0" rtlCol="0" anchor="ctr"/>
           <a:lstStyle/>
           <a:p>
-            <a:pPr indent="0" marL="0">
+            <a:pPr marL="0" indent="0">
               <a:buNone/>
             </a:pPr>
             <a:r>
@@ -4165,7 +3618,7 @@
           <a:bodyPr wrap="square" lIns="0" tIns="0" rIns="0" bIns="0" rtlCol="0" anchor="ctr"/>
           <a:lstStyle/>
           <a:p>
-            <a:pPr indent="0" marL="0">
+            <a:pPr marL="0" indent="0">
               <a:lnSpc>
                 <a:spcPts val="1700"/>
               </a:lnSpc>
@@ -4185,7 +3638,7 @@
             <a:endParaRPr lang="en-US" sz="1250" dirty="0"/>
           </a:p>
           <a:p>
-            <a:pPr indent="0" marL="0">
+            <a:pPr marL="0" indent="0">
               <a:lnSpc>
                 <a:spcPts val="1700"/>
               </a:lnSpc>
@@ -4227,7 +3680,7 @@
           <a:bodyPr wrap="square" lIns="0" tIns="0" rIns="0" bIns="0" rtlCol="0" anchor="ctr"/>
           <a:lstStyle/>
           <a:p>
-            <a:pPr algn="ctr" indent="0" marL="0">
+            <a:pPr marL="0" indent="0" algn="ctr">
               <a:buNone/>
             </a:pPr>
             <a:r>
@@ -4271,13 +3724,20 @@
             <a:prstDash val="solid"/>
           </a:ln>
           <a:effectLst>
-            <a:outerShdw sx="100000" sy="100000" kx="0" ky="0" algn="bl" rotWithShape="0" blurRad="177800" dist="25400" dir="5400000">
+            <a:outerShdw blurRad="177800" dist="25400" dir="5400000" algn="bl" rotWithShape="0">
               <a:srgbClr val="0A1622">
                 <a:alpha val="16000"/>
               </a:srgbClr>
             </a:outerShdw>
           </a:effectLst>
         </p:spPr>
+        <p:txBody>
+          <a:bodyPr/>
+          <a:lstStyle/>
+          <a:p>
+            <a:endParaRPr lang="en-BE"/>
+          </a:p>
+        </p:txBody>
       </p:sp>
       <p:sp>
         <p:nvSpPr>
@@ -4303,6 +3763,13 @@
             <a:prstDash val="solid"/>
           </a:ln>
         </p:spPr>
+        <p:txBody>
+          <a:bodyPr/>
+          <a:lstStyle/>
+          <a:p>
+            <a:endParaRPr lang="en-BE"/>
+          </a:p>
+        </p:txBody>
       </p:sp>
       <p:sp>
         <p:nvSpPr>
@@ -4325,7 +3792,7 @@
           <a:bodyPr wrap="square" lIns="0" tIns="0" rIns="0" bIns="0" rtlCol="0" anchor="ctr"/>
           <a:lstStyle/>
           <a:p>
-            <a:pPr algn="ctr" indent="0" marL="0">
+            <a:pPr marL="0" indent="0" algn="ctr">
               <a:buNone/>
             </a:pPr>
             <a:r>
@@ -4364,7 +3831,7 @@
           <a:bodyPr wrap="square" lIns="0" tIns="0" rIns="0" bIns="0" rtlCol="0" anchor="ctr"/>
           <a:lstStyle/>
           <a:p>
-            <a:pPr indent="0" marL="0">
+            <a:pPr marL="0" indent="0">
               <a:buNone/>
             </a:pPr>
             <a:r>
@@ -4403,7 +3870,7 @@
           <a:bodyPr wrap="square" lIns="0" tIns="0" rIns="0" bIns="0" rtlCol="0" anchor="ctr"/>
           <a:lstStyle/>
           <a:p>
-            <a:pPr indent="0" marL="0">
+            <a:pPr marL="0" indent="0">
               <a:lnSpc>
                 <a:spcPts val="1700"/>
               </a:lnSpc>
@@ -4423,7 +3890,7 @@
             <a:endParaRPr lang="en-US" sz="1250" dirty="0"/>
           </a:p>
           <a:p>
-            <a:pPr indent="0" marL="0">
+            <a:pPr marL="0" indent="0">
               <a:lnSpc>
                 <a:spcPts val="1700"/>
               </a:lnSpc>
@@ -4461,7 +3928,10 @@
             </a:avLst>
           </a:prstGeom>
           <a:solidFill>
-            <a:srgbClr val="16324F"/>
+            <a:schemeClr val="accent1">
+              <a:lumMod val="60000"/>
+              <a:lumOff val="40000"/>
+            </a:schemeClr>
           </a:solidFill>
           <a:ln w="12700">
             <a:solidFill>
@@ -4470,13 +3940,20 @@
             <a:prstDash val="solid"/>
           </a:ln>
           <a:effectLst>
-            <a:outerShdw sx="100000" sy="100000" kx="0" ky="0" algn="bl" rotWithShape="0" blurRad="177800" dist="25400" dir="5400000">
+            <a:outerShdw blurRad="177800" dist="25400" dir="5400000" algn="bl" rotWithShape="0">
               <a:srgbClr val="0A1622">
                 <a:alpha val="16000"/>
               </a:srgbClr>
             </a:outerShdw>
           </a:effectLst>
         </p:spPr>
+        <p:txBody>
+          <a:bodyPr/>
+          <a:lstStyle/>
+          <a:p>
+            <a:endParaRPr lang="en-BE"/>
+          </a:p>
+        </p:txBody>
       </p:sp>
       <p:sp>
         <p:nvSpPr>
@@ -4499,13 +3976,15 @@
           <a:bodyPr wrap="square" lIns="0" tIns="0" rIns="0" bIns="0" rtlCol="0" anchor="ctr"/>
           <a:lstStyle/>
           <a:p>
-            <a:pPr indent="0" marL="0">
+            <a:pPr marL="0" indent="0">
               <a:buNone/>
             </a:pPr>
             <a:r>
               <a:rPr lang="en-US" sz="1700" b="1" dirty="0">
                 <a:solidFill>
-                  <a:srgbClr val="2DD4BF"/>
+                  <a:schemeClr val="tx2">
+                    <a:lumMod val="50000"/>
+                  </a:schemeClr>
                 </a:solidFill>
                 <a:latin typeface="Calibri" pitchFamily="34" charset="0"/>
                 <a:ea typeface="Calibri" pitchFamily="34" charset="-122"/>
@@ -4513,7 +3992,13 @@
               </a:rPr>
               <a:t>Nothing is explained until a person confirms what was read.</a:t>
             </a:r>
-            <a:endParaRPr lang="en-US" sz="1700" dirty="0"/>
+            <a:endParaRPr lang="en-US" sz="1700" dirty="0">
+              <a:solidFill>
+                <a:schemeClr val="tx2">
+                  <a:lumMod val="50000"/>
+                </a:schemeClr>
+              </a:solidFill>
+            </a:endParaRPr>
           </a:p>
         </p:txBody>
       </p:sp>
@@ -4538,7 +4023,7 @@
           <a:bodyPr wrap="square" lIns="0" tIns="0" rIns="0" bIns="0" rtlCol="0" anchor="ctr"/>
           <a:lstStyle/>
           <a:p>
-            <a:pPr indent="0" marL="0">
+            <a:pPr marL="0" indent="0">
               <a:lnSpc>
                 <a:spcPts val="1800"/>
               </a:lnSpc>
@@ -4547,7 +4032,9 @@
             <a:r>
               <a:rPr lang="en-US" sz="1350" dirty="0">
                 <a:solidFill>
-                  <a:srgbClr val="94A3B8"/>
+                  <a:schemeClr val="tx2">
+                    <a:lumMod val="50000"/>
+                  </a:schemeClr>
                 </a:solidFill>
                 <a:latin typeface="Calibri" pitchFamily="34" charset="0"/>
                 <a:ea typeface="Calibri" pitchFamily="34" charset="-122"/>
@@ -4555,7 +4042,13 @@
               </a:rPr>
               <a:t>Confidence tells you the OCR was sure. It does not tell you it was right — so the review step is mandatory, not conditional. It is also where a misread digit gets caught by the one person who can see the paper.</a:t>
             </a:r>
-            <a:endParaRPr lang="en-US" sz="1350" dirty="0"/>
+            <a:endParaRPr lang="en-US" sz="1350" dirty="0">
+              <a:solidFill>
+                <a:schemeClr val="tx2">
+                  <a:lumMod val="50000"/>
+                </a:schemeClr>
+              </a:solidFill>
+            </a:endParaRPr>
           </a:p>
         </p:txBody>
       </p:sp>
@@ -4575,6 +4068,7 @@
         <a:solidFill>
           <a:srgbClr val="16324F"/>
         </a:solidFill>
+        <a:effectLst/>
       </p:bgPr>
     </p:bg>
     <p:spTree>
@@ -4612,11 +4106,11 @@
           <a:bodyPr wrap="square" lIns="0" tIns="0" rIns="0" bIns="0" rtlCol="0" anchor="ctr"/>
           <a:lstStyle/>
           <a:p>
-            <a:pPr indent="0" marL="0">
-              <a:buNone/>
-            </a:pPr>
-            <a:r>
-              <a:rPr lang="en-US" sz="1300" b="1" spc="200" kern="0" dirty="0">
+            <a:pPr marL="0" indent="0">
+              <a:buNone/>
+            </a:pPr>
+            <a:r>
+              <a:rPr lang="en-US" sz="1300" b="1" kern="0" spc="200" dirty="0">
                 <a:solidFill>
                   <a:srgbClr val="2DD4BF"/>
                 </a:solidFill>
@@ -4651,7 +4145,7 @@
           <a:bodyPr wrap="square" lIns="0" tIns="0" rIns="0" bIns="0" rtlCol="0" anchor="ctr"/>
           <a:lstStyle/>
           <a:p>
-            <a:pPr indent="0" marL="0">
+            <a:pPr marL="0" indent="0">
               <a:buNone/>
             </a:pPr>
             <a:r>
@@ -4690,7 +4184,7 @@
           <a:bodyPr wrap="square" lIns="0" tIns="0" rIns="0" bIns="0" rtlCol="0" anchor="ctr"/>
           <a:lstStyle/>
           <a:p>
-            <a:pPr indent="0" marL="0">
+            <a:pPr marL="0" indent="0">
               <a:buNone/>
             </a:pPr>
             <a:r>
@@ -4734,6 +4228,13 @@
             <a:prstDash val="solid"/>
           </a:ln>
         </p:spPr>
+        <p:txBody>
+          <a:bodyPr/>
+          <a:lstStyle/>
+          <a:p>
+            <a:endParaRPr lang="en-BE"/>
+          </a:p>
+        </p:txBody>
       </p:sp>
       <p:sp>
         <p:nvSpPr>
@@ -4756,7 +4257,7 @@
           <a:bodyPr wrap="square" lIns="0" tIns="0" rIns="0" bIns="0" rtlCol="0" anchor="ctr"/>
           <a:lstStyle/>
           <a:p>
-            <a:pPr indent="0" marL="0">
+            <a:pPr marL="0" indent="0">
               <a:lnSpc>
                 <a:spcPts val="2400"/>
               </a:lnSpc>
@@ -4798,7 +4299,7 @@
           <a:bodyPr wrap="square" lIns="0" tIns="0" rIns="0" bIns="0" rtlCol="0" anchor="ctr"/>
           <a:lstStyle/>
           <a:p>
-            <a:pPr indent="0" marL="0">
+            <a:pPr marL="0" indent="0">
               <a:lnSpc>
                 <a:spcPts val="1800"/>
               </a:lnSpc>
@@ -4845,6 +4346,13 @@
             <a:prstDash val="solid"/>
           </a:ln>
         </p:spPr>
+        <p:txBody>
+          <a:bodyPr/>
+          <a:lstStyle/>
+          <a:p>
+            <a:endParaRPr lang="en-BE"/>
+          </a:p>
+        </p:txBody>
       </p:sp>
       <p:sp>
         <p:nvSpPr>
@@ -4867,7 +4375,7 @@
           <a:bodyPr wrap="square" lIns="0" tIns="0" rIns="0" bIns="0" rtlCol="0" anchor="ctr"/>
           <a:lstStyle/>
           <a:p>
-            <a:pPr indent="0" marL="0">
+            <a:pPr marL="0" indent="0">
               <a:lnSpc>
                 <a:spcPts val="2400"/>
               </a:lnSpc>
@@ -4909,7 +4417,7 @@
           <a:bodyPr wrap="square" lIns="0" tIns="0" rIns="0" bIns="0" rtlCol="0" anchor="ctr"/>
           <a:lstStyle/>
           <a:p>
-            <a:pPr indent="0" marL="0">
+            <a:pPr marL="0" indent="0">
               <a:lnSpc>
                 <a:spcPts val="1800"/>
               </a:lnSpc>
@@ -4956,6 +4464,13 @@
             <a:prstDash val="solid"/>
           </a:ln>
         </p:spPr>
+        <p:txBody>
+          <a:bodyPr/>
+          <a:lstStyle/>
+          <a:p>
+            <a:endParaRPr lang="en-BE"/>
+          </a:p>
+        </p:txBody>
       </p:sp>
       <p:sp>
         <p:nvSpPr>
@@ -4978,7 +4493,7 @@
           <a:bodyPr wrap="square" lIns="0" tIns="0" rIns="0" bIns="0" rtlCol="0" anchor="ctr"/>
           <a:lstStyle/>
           <a:p>
-            <a:pPr indent="0" marL="0">
+            <a:pPr marL="0" indent="0">
               <a:lnSpc>
                 <a:spcPts val="2400"/>
               </a:lnSpc>
@@ -5020,7 +4535,7 @@
           <a:bodyPr wrap="square" lIns="0" tIns="0" rIns="0" bIns="0" rtlCol="0" anchor="ctr"/>
           <a:lstStyle/>
           <a:p>
-            <a:pPr indent="0" marL="0">
+            <a:pPr marL="0" indent="0">
               <a:lnSpc>
                 <a:spcPts val="1800"/>
               </a:lnSpc>
@@ -5062,7 +4577,7 @@
           <a:bodyPr wrap="square" lIns="0" tIns="0" rIns="0" bIns="0" rtlCol="0" anchor="ctr"/>
           <a:lstStyle/>
           <a:p>
-            <a:pPr indent="0" marL="0">
+            <a:pPr marL="0" indent="0">
               <a:buNone/>
             </a:pPr>
             <a:r>
@@ -5096,6 +4611,7 @@
         <a:solidFill>
           <a:srgbClr val="F8FAFC"/>
         </a:solidFill>
+        <a:effectLst/>
       </p:bgPr>
     </p:bg>
     <p:spTree>
@@ -5133,11 +4649,11 @@
           <a:bodyPr wrap="square" lIns="0" tIns="0" rIns="0" bIns="0" rtlCol="0" anchor="ctr"/>
           <a:lstStyle/>
           <a:p>
-            <a:pPr indent="0" marL="0">
-              <a:buNone/>
-            </a:pPr>
-            <a:r>
-              <a:rPr lang="en-US" sz="1300" b="1" spc="200" kern="0" dirty="0">
+            <a:pPr marL="0" indent="0">
+              <a:buNone/>
+            </a:pPr>
+            <a:r>
+              <a:rPr lang="en-US" sz="1300" b="1" kern="0" spc="200" dirty="0">
                 <a:solidFill>
                   <a:srgbClr val="0F766E"/>
                 </a:solidFill>
@@ -5172,7 +4688,7 @@
           <a:bodyPr wrap="square" lIns="0" tIns="0" rIns="0" bIns="0" rtlCol="0" anchor="ctr"/>
           <a:lstStyle/>
           <a:p>
-            <a:pPr indent="0" marL="0">
+            <a:pPr marL="0" indent="0">
               <a:buNone/>
             </a:pPr>
             <a:r>
@@ -5211,7 +4727,7 @@
           <a:bodyPr wrap="square" lIns="0" tIns="0" rIns="0" bIns="0" rtlCol="0" anchor="ctr"/>
           <a:lstStyle/>
           <a:p>
-            <a:pPr indent="0" marL="0">
+            <a:pPr marL="0" indent="0">
               <a:buNone/>
             </a:pPr>
             <a:r>
@@ -5255,13 +4771,20 @@
             <a:prstDash val="solid"/>
           </a:ln>
           <a:effectLst>
-            <a:outerShdw sx="100000" sy="100000" kx="0" ky="0" algn="bl" rotWithShape="0" blurRad="177800" dist="25400" dir="5400000">
+            <a:outerShdw blurRad="177800" dist="25400" dir="5400000" algn="bl" rotWithShape="0">
               <a:srgbClr val="0A1622">
                 <a:alpha val="16000"/>
               </a:srgbClr>
             </a:outerShdw>
           </a:effectLst>
         </p:spPr>
+        <p:txBody>
+          <a:bodyPr/>
+          <a:lstStyle/>
+          <a:p>
+            <a:endParaRPr lang="en-BE"/>
+          </a:p>
+        </p:txBody>
       </p:sp>
       <p:sp>
         <p:nvSpPr>
@@ -5284,11 +4807,11 @@
           <a:bodyPr wrap="square" lIns="0" tIns="0" rIns="0" bIns="0" rtlCol="0" anchor="ctr"/>
           <a:lstStyle/>
           <a:p>
-            <a:pPr indent="0" marL="0">
-              <a:buNone/>
-            </a:pPr>
-            <a:r>
-              <a:rPr lang="en-US" sz="1100" b="1" spc="150" kern="0" dirty="0">
+            <a:pPr marL="0" indent="0">
+              <a:buNone/>
+            </a:pPr>
+            <a:r>
+              <a:rPr lang="en-US" sz="1100" b="1" kern="0" spc="150" dirty="0">
                 <a:solidFill>
                   <a:srgbClr val="64748B"/>
                 </a:solidFill>
@@ -5323,7 +4846,7 @@
           <a:bodyPr wrap="square" lIns="0" tIns="0" rIns="0" bIns="0" rtlCol="0" anchor="ctr"/>
           <a:lstStyle/>
           <a:p>
-            <a:pPr indent="0" marL="0">
+            <a:pPr marL="0" indent="0">
               <a:buNone/>
             </a:pPr>
             <a:r>
@@ -5362,7 +4885,7 @@
           <a:bodyPr wrap="square" lIns="0" tIns="0" rIns="0" bIns="0" rtlCol="0" anchor="ctr"/>
           <a:lstStyle/>
           <a:p>
-            <a:pPr indent="0" marL="0">
+            <a:pPr marL="0" indent="0">
               <a:buNone/>
             </a:pPr>
             <a:r>
@@ -5401,7 +4924,7 @@
           <a:bodyPr wrap="square" lIns="0" tIns="0" rIns="0" bIns="0" rtlCol="0" anchor="ctr"/>
           <a:lstStyle/>
           <a:p>
-            <a:pPr indent="0" marL="0">
+            <a:pPr marL="0" indent="0">
               <a:lnSpc>
                 <a:spcPts val="1600"/>
               </a:lnSpc>
@@ -5443,7 +4966,7 @@
           <a:bodyPr wrap="square" lIns="0" tIns="0" rIns="0" bIns="0" rtlCol="0" anchor="ctr"/>
           <a:lstStyle/>
           <a:p>
-            <a:pPr indent="0" marL="0">
+            <a:pPr marL="0" indent="0">
               <a:buNone/>
             </a:pPr>
             <a:r>
@@ -5482,7 +5005,7 @@
           <a:bodyPr wrap="square" lIns="0" tIns="0" rIns="0" bIns="0" rtlCol="0" anchor="ctr"/>
           <a:lstStyle/>
           <a:p>
-            <a:pPr algn="ctr" indent="0" marL="0">
+            <a:pPr marL="0" indent="0" algn="ctr">
               <a:buNone/>
             </a:pPr>
             <a:r>
@@ -5521,7 +5044,7 @@
           <a:bodyPr wrap="square" lIns="0" tIns="0" rIns="0" bIns="0" rtlCol="0" anchor="ctr"/>
           <a:lstStyle/>
           <a:p>
-            <a:pPr algn="ctr" indent="0" marL="0">
+            <a:pPr marL="0" indent="0" algn="ctr">
               <a:buNone/>
             </a:pPr>
             <a:r>
@@ -5565,13 +5088,20 @@
             <a:prstDash val="solid"/>
           </a:ln>
           <a:effectLst>
-            <a:outerShdw sx="100000" sy="100000" kx="0" ky="0" algn="bl" rotWithShape="0" blurRad="177800" dist="25400" dir="5400000">
+            <a:outerShdw blurRad="177800" dist="25400" dir="5400000" algn="bl" rotWithShape="0">
               <a:srgbClr val="0A1622">
                 <a:alpha val="16000"/>
               </a:srgbClr>
             </a:outerShdw>
           </a:effectLst>
         </p:spPr>
+        <p:txBody>
+          <a:bodyPr/>
+          <a:lstStyle/>
+          <a:p>
+            <a:endParaRPr lang="en-BE"/>
+          </a:p>
+        </p:txBody>
       </p:sp>
       <p:sp>
         <p:nvSpPr>
@@ -5594,11 +5124,11 @@
           <a:bodyPr wrap="square" lIns="0" tIns="0" rIns="0" bIns="0" rtlCol="0" anchor="ctr"/>
           <a:lstStyle/>
           <a:p>
-            <a:pPr indent="0" marL="0">
-              <a:buNone/>
-            </a:pPr>
-            <a:r>
-              <a:rPr lang="en-US" sz="1100" b="1" spc="150" kern="0" dirty="0">
+            <a:pPr marL="0" indent="0">
+              <a:buNone/>
+            </a:pPr>
+            <a:r>
+              <a:rPr lang="en-US" sz="1100" b="1" kern="0" spc="150" dirty="0">
                 <a:solidFill>
                   <a:srgbClr val="0F766E"/>
                 </a:solidFill>
@@ -5633,7 +5163,7 @@
           <a:bodyPr wrap="square" lIns="0" tIns="0" rIns="0" bIns="0" rtlCol="0" anchor="ctr"/>
           <a:lstStyle/>
           <a:p>
-            <a:pPr indent="0" marL="0">
+            <a:pPr marL="0" indent="0">
               <a:buNone/>
             </a:pPr>
             <a:r>
@@ -5672,7 +5202,7 @@
           <a:bodyPr wrap="square" lIns="0" tIns="0" rIns="0" bIns="0" rtlCol="0" anchor="ctr"/>
           <a:lstStyle/>
           <a:p>
-            <a:pPr indent="0" marL="0">
+            <a:pPr marL="0" indent="0">
               <a:buNone/>
             </a:pPr>
             <a:r>
@@ -5711,7 +5241,7 @@
           <a:bodyPr wrap="square" lIns="0" tIns="0" rIns="0" bIns="0" rtlCol="0" anchor="ctr"/>
           <a:lstStyle/>
           <a:p>
-            <a:pPr indent="0" marL="0">
+            <a:pPr marL="0" indent="0">
               <a:lnSpc>
                 <a:spcPts val="1600"/>
               </a:lnSpc>
@@ -5753,7 +5283,7 @@
           <a:bodyPr wrap="square" lIns="0" tIns="0" rIns="0" bIns="0" rtlCol="0" anchor="ctr"/>
           <a:lstStyle/>
           <a:p>
-            <a:pPr indent="0" marL="0">
+            <a:pPr marL="0" indent="0">
               <a:buNone/>
             </a:pPr>
             <a:r>
@@ -5788,7 +5318,9 @@
             </a:avLst>
           </a:prstGeom>
           <a:solidFill>
-            <a:srgbClr val="16324F"/>
+            <a:schemeClr val="accent1">
+              <a:lumMod val="75000"/>
+            </a:schemeClr>
           </a:solidFill>
           <a:ln w="12700">
             <a:solidFill>
@@ -5797,13 +5329,20 @@
             <a:prstDash val="solid"/>
           </a:ln>
           <a:effectLst>
-            <a:outerShdw sx="100000" sy="100000" kx="0" ky="0" algn="bl" rotWithShape="0" blurRad="177800" dist="25400" dir="5400000">
+            <a:outerShdw blurRad="177800" dist="25400" dir="5400000" algn="bl" rotWithShape="0">
               <a:srgbClr val="0A1622">
                 <a:alpha val="16000"/>
               </a:srgbClr>
             </a:outerShdw>
           </a:effectLst>
         </p:spPr>
+        <p:txBody>
+          <a:bodyPr/>
+          <a:lstStyle/>
+          <a:p>
+            <a:endParaRPr lang="en-BE"/>
+          </a:p>
+        </p:txBody>
       </p:sp>
       <p:sp>
         <p:nvSpPr>
@@ -5826,7 +5365,7 @@
           <a:bodyPr wrap="square" lIns="0" tIns="0" rIns="0" bIns="0" rtlCol="0" anchor="ctr"/>
           <a:lstStyle/>
           <a:p>
-            <a:pPr indent="0" marL="0">
+            <a:pPr marL="0" indent="0">
               <a:buNone/>
             </a:pPr>
             <a:r>
@@ -5865,7 +5404,7 @@
           <a:bodyPr wrap="square" lIns="0" tIns="0" rIns="0" bIns="0" rtlCol="0" anchor="ctr"/>
           <a:lstStyle/>
           <a:p>
-            <a:pPr indent="0" marL="0">
+            <a:pPr marL="0" indent="0">
               <a:buNone/>
             </a:pPr>
             <a:r>
@@ -5899,6 +5438,7 @@
         <a:solidFill>
           <a:srgbClr val="F8FAFC"/>
         </a:solidFill>
+        <a:effectLst/>
       </p:bgPr>
     </p:bg>
     <p:spTree>
@@ -5936,11 +5476,11 @@
           <a:bodyPr wrap="square" lIns="0" tIns="0" rIns="0" bIns="0" rtlCol="0" anchor="ctr"/>
           <a:lstStyle/>
           <a:p>
-            <a:pPr indent="0" marL="0">
-              <a:buNone/>
-            </a:pPr>
-            <a:r>
-              <a:rPr lang="en-US" sz="1300" b="1" spc="200" kern="0" dirty="0">
+            <a:pPr marL="0" indent="0">
+              <a:buNone/>
+            </a:pPr>
+            <a:r>
+              <a:rPr lang="en-US" sz="1300" b="1" kern="0" spc="200" dirty="0">
                 <a:solidFill>
                   <a:srgbClr val="0F766E"/>
                 </a:solidFill>
@@ -5975,7 +5515,7 @@
           <a:bodyPr wrap="square" lIns="0" tIns="0" rIns="0" bIns="0" rtlCol="0" anchor="ctr"/>
           <a:lstStyle/>
           <a:p>
-            <a:pPr indent="0" marL="0">
+            <a:pPr marL="0" indent="0">
               <a:buNone/>
             </a:pPr>
             <a:r>
@@ -6014,7 +5554,7 @@
           <a:bodyPr wrap="square" lIns="0" tIns="0" rIns="0" bIns="0" rtlCol="0" anchor="ctr"/>
           <a:lstStyle/>
           <a:p>
-            <a:pPr indent="0" marL="0">
+            <a:pPr marL="0" indent="0">
               <a:buNone/>
             </a:pPr>
             <a:r>
@@ -6058,13 +5598,20 @@
             <a:prstDash val="solid"/>
           </a:ln>
           <a:effectLst>
-            <a:outerShdw sx="100000" sy="100000" kx="0" ky="0" algn="bl" rotWithShape="0" blurRad="177800" dist="25400" dir="5400000">
+            <a:outerShdw blurRad="177800" dist="25400" dir="5400000" algn="bl" rotWithShape="0">
               <a:srgbClr val="0A1622">
                 <a:alpha val="16000"/>
               </a:srgbClr>
             </a:outerShdw>
           </a:effectLst>
         </p:spPr>
+        <p:txBody>
+          <a:bodyPr/>
+          <a:lstStyle/>
+          <a:p>
+            <a:endParaRPr lang="en-BE"/>
+          </a:p>
+        </p:txBody>
       </p:sp>
       <p:sp>
         <p:nvSpPr>
@@ -6087,7 +5634,7 @@
           <a:bodyPr wrap="square" lIns="0" tIns="0" rIns="0" bIns="0" rtlCol="0" anchor="ctr"/>
           <a:lstStyle/>
           <a:p>
-            <a:pPr indent="0" marL="0">
+            <a:pPr marL="0" indent="0">
               <a:buNone/>
             </a:pPr>
             <a:r>
@@ -6129,6 +5676,13 @@
             <a:prstDash val="solid"/>
           </a:ln>
         </p:spPr>
+        <p:txBody>
+          <a:bodyPr/>
+          <a:lstStyle/>
+          <a:p>
+            <a:endParaRPr lang="en-BE"/>
+          </a:p>
+        </p:txBody>
       </p:sp>
       <p:sp>
         <p:nvSpPr>
@@ -6151,7 +5705,7 @@
           <a:bodyPr wrap="square" lIns="0" tIns="0" rIns="0" bIns="0" rtlCol="0" anchor="ctr"/>
           <a:lstStyle/>
           <a:p>
-            <a:pPr indent="0" marL="0">
+            <a:pPr marL="0" indent="0">
               <a:buNone/>
             </a:pPr>
             <a:r>
@@ -6193,6 +5747,13 @@
             <a:prstDash val="solid"/>
           </a:ln>
         </p:spPr>
+        <p:txBody>
+          <a:bodyPr/>
+          <a:lstStyle/>
+          <a:p>
+            <a:endParaRPr lang="en-BE"/>
+          </a:p>
+        </p:txBody>
       </p:sp>
       <p:sp>
         <p:nvSpPr>
@@ -6215,7 +5776,7 @@
           <a:bodyPr wrap="square" lIns="0" tIns="0" rIns="0" bIns="0" rtlCol="0" anchor="ctr"/>
           <a:lstStyle/>
           <a:p>
-            <a:pPr indent="0" marL="0">
+            <a:pPr marL="0" indent="0">
               <a:buNone/>
             </a:pPr>
             <a:r>
@@ -6257,6 +5818,13 @@
             <a:prstDash val="solid"/>
           </a:ln>
         </p:spPr>
+        <p:txBody>
+          <a:bodyPr/>
+          <a:lstStyle/>
+          <a:p>
+            <a:endParaRPr lang="en-BE"/>
+          </a:p>
+        </p:txBody>
       </p:sp>
       <p:sp>
         <p:nvSpPr>
@@ -6279,7 +5847,7 @@
           <a:bodyPr wrap="square" lIns="0" tIns="0" rIns="0" bIns="0" rtlCol="0" anchor="ctr"/>
           <a:lstStyle/>
           <a:p>
-            <a:pPr indent="0" marL="0">
+            <a:pPr marL="0" indent="0">
               <a:buNone/>
             </a:pPr>
             <a:r>
@@ -6321,6 +5889,13 @@
             <a:prstDash val="solid"/>
           </a:ln>
         </p:spPr>
+        <p:txBody>
+          <a:bodyPr/>
+          <a:lstStyle/>
+          <a:p>
+            <a:endParaRPr lang="en-BE"/>
+          </a:p>
+        </p:txBody>
       </p:sp>
       <p:sp>
         <p:nvSpPr>
@@ -6343,7 +5918,7 @@
           <a:bodyPr wrap="square" lIns="0" tIns="0" rIns="0" bIns="0" rtlCol="0" anchor="ctr"/>
           <a:lstStyle/>
           <a:p>
-            <a:pPr indent="0" marL="0">
+            <a:pPr marL="0" indent="0">
               <a:buNone/>
             </a:pPr>
             <a:r>
@@ -6378,7 +5953,9 @@
             </a:avLst>
           </a:prstGeom>
           <a:solidFill>
-            <a:srgbClr val="16324F"/>
+            <a:schemeClr val="accent1">
+              <a:lumMod val="75000"/>
+            </a:schemeClr>
           </a:solidFill>
           <a:ln w="12700">
             <a:solidFill>
@@ -6387,13 +5964,20 @@
             <a:prstDash val="solid"/>
           </a:ln>
           <a:effectLst>
-            <a:outerShdw sx="100000" sy="100000" kx="0" ky="0" algn="bl" rotWithShape="0" blurRad="177800" dist="25400" dir="5400000">
+            <a:outerShdw blurRad="177800" dist="25400" dir="5400000" algn="bl" rotWithShape="0">
               <a:srgbClr val="0A1622">
                 <a:alpha val="16000"/>
               </a:srgbClr>
             </a:outerShdw>
           </a:effectLst>
         </p:spPr>
+        <p:txBody>
+          <a:bodyPr/>
+          <a:lstStyle/>
+          <a:p>
+            <a:endParaRPr lang="en-BE"/>
+          </a:p>
+        </p:txBody>
       </p:sp>
       <p:sp>
         <p:nvSpPr>
@@ -6416,7 +6000,7 @@
           <a:bodyPr wrap="square" lIns="0" tIns="0" rIns="0" bIns="0" rtlCol="0" anchor="ctr"/>
           <a:lstStyle/>
           <a:p>
-            <a:pPr indent="0" marL="0">
+            <a:pPr marL="0" indent="0">
               <a:buNone/>
             </a:pPr>
             <a:r>
@@ -6455,7 +6039,7 @@
           <a:bodyPr wrap="square" lIns="0" tIns="0" rIns="0" bIns="0" rtlCol="0" anchor="ctr"/>
           <a:lstStyle/>
           <a:p>
-            <a:pPr indent="0" marL="0">
+            <a:pPr marL="0" indent="0">
               <a:lnSpc>
                 <a:spcPts val="1800"/>
               </a:lnSpc>
@@ -6497,7 +6081,7 @@
           <a:bodyPr wrap="square" lIns="0" tIns="0" rIns="0" bIns="0" rtlCol="0" anchor="ctr"/>
           <a:lstStyle/>
           <a:p>
-            <a:pPr indent="0" marL="0">
+            <a:pPr marL="0" indent="0">
               <a:buNone/>
             </a:pPr>
             <a:r>
@@ -6536,7 +6120,7 @@
           <a:bodyPr wrap="square" lIns="0" tIns="0" rIns="0" bIns="0" rtlCol="0" anchor="ctr"/>
           <a:lstStyle/>
           <a:p>
-            <a:pPr indent="0" marL="0">
+            <a:pPr marL="0" indent="0">
               <a:buNone/>
             </a:pPr>
             <a:r>
@@ -6575,7 +6159,7 @@
           <a:bodyPr wrap="square" lIns="0" tIns="0" rIns="0" bIns="0" rtlCol="0" anchor="ctr"/>
           <a:lstStyle/>
           <a:p>
-            <a:pPr indent="0" marL="0">
+            <a:pPr marL="0" indent="0">
               <a:lnSpc>
                 <a:spcPts val="1800"/>
               </a:lnSpc>
@@ -6617,7 +6201,7 @@
           <a:bodyPr wrap="square" lIns="0" tIns="0" rIns="0" bIns="0" rtlCol="0" anchor="ctr"/>
           <a:lstStyle/>
           <a:p>
-            <a:pPr indent="0" marL="0">
+            <a:pPr marL="0" indent="0">
               <a:buNone/>
             </a:pPr>
             <a:r>
@@ -6649,8 +6233,9 @@
     <p:bg>
       <p:bgPr>
         <a:solidFill>
-          <a:srgbClr val="16324F"/>
+          <a:schemeClr val="bg1"/>
         </a:solidFill>
+        <a:effectLst/>
       </p:bgPr>
     </p:bg>
     <p:spTree>
@@ -6688,11 +6273,11 @@
           <a:bodyPr wrap="square" lIns="0" tIns="0" rIns="0" bIns="0" rtlCol="0" anchor="ctr"/>
           <a:lstStyle/>
           <a:p>
-            <a:pPr indent="0" marL="0">
-              <a:buNone/>
-            </a:pPr>
-            <a:r>
-              <a:rPr lang="en-US" sz="1300" b="1" spc="200" kern="0" dirty="0">
+            <a:pPr marL="0" indent="0">
+              <a:buNone/>
+            </a:pPr>
+            <a:r>
+              <a:rPr lang="en-US" sz="1300" b="1" kern="0" spc="200" dirty="0">
                 <a:solidFill>
                   <a:srgbClr val="2DD4BF"/>
                 </a:solidFill>
@@ -6727,13 +6312,15 @@
           <a:bodyPr wrap="square" lIns="0" tIns="0" rIns="0" bIns="0" rtlCol="0" anchor="ctr"/>
           <a:lstStyle/>
           <a:p>
-            <a:pPr indent="0" marL="0">
+            <a:pPr marL="0" indent="0">
               <a:buNone/>
             </a:pPr>
             <a:r>
               <a:rPr lang="en-US" sz="3600" b="1" dirty="0">
                 <a:solidFill>
-                  <a:srgbClr val="FFFFFF"/>
+                  <a:schemeClr val="accent1">
+                    <a:lumMod val="50000"/>
+                  </a:schemeClr>
                 </a:solidFill>
                 <a:latin typeface="Cambria" pitchFamily="34" charset="0"/>
                 <a:ea typeface="Cambria" pitchFamily="34" charset="-122"/>
@@ -6741,7 +6328,13 @@
               </a:rPr>
               <a:t>Served on NVIDIA, priced like a rounding error</a:t>
             </a:r>
-            <a:endParaRPr lang="en-US" sz="3600" dirty="0"/>
+            <a:endParaRPr lang="en-US" sz="3600" dirty="0">
+              <a:solidFill>
+                <a:schemeClr val="accent1">
+                  <a:lumMod val="50000"/>
+                </a:schemeClr>
+              </a:solidFill>
+            </a:endParaRPr>
           </a:p>
         </p:txBody>
       </p:sp>
@@ -6766,7 +6359,7 @@
           <a:bodyPr wrap="square" lIns="0" tIns="0" rIns="0" bIns="0" rtlCol="0" anchor="ctr"/>
           <a:lstStyle/>
           <a:p>
-            <a:pPr indent="0" marL="0">
+            <a:pPr marL="0" indent="0">
               <a:buNone/>
             </a:pPr>
             <a:r>
@@ -6810,6 +6403,13 @@
             <a:prstDash val="solid"/>
           </a:ln>
         </p:spPr>
+        <p:txBody>
+          <a:bodyPr/>
+          <a:lstStyle/>
+          <a:p>
+            <a:endParaRPr lang="en-BE"/>
+          </a:p>
+        </p:txBody>
       </p:sp>
       <p:sp>
         <p:nvSpPr>
@@ -6832,7 +6432,7 @@
           <a:bodyPr wrap="square" lIns="0" tIns="0" rIns="0" bIns="0" rtlCol="0" anchor="ctr"/>
           <a:lstStyle/>
           <a:p>
-            <a:pPr indent="0" marL="0">
+            <a:pPr marL="0" indent="0">
               <a:buNone/>
             </a:pPr>
             <a:r>
@@ -6871,7 +6471,7 @@
           <a:bodyPr wrap="square" lIns="0" tIns="0" rIns="0" bIns="0" rtlCol="0" anchor="ctr"/>
           <a:lstStyle/>
           <a:p>
-            <a:pPr indent="0" marL="0">
+            <a:pPr marL="0" indent="0">
               <a:lnSpc>
                 <a:spcPts val="1700"/>
               </a:lnSpc>
@@ -6918,6 +6518,13 @@
             <a:prstDash val="solid"/>
           </a:ln>
         </p:spPr>
+        <p:txBody>
+          <a:bodyPr/>
+          <a:lstStyle/>
+          <a:p>
+            <a:endParaRPr lang="en-BE"/>
+          </a:p>
+        </p:txBody>
       </p:sp>
       <p:sp>
         <p:nvSpPr>
@@ -6940,7 +6547,7 @@
           <a:bodyPr wrap="square" lIns="0" tIns="0" rIns="0" bIns="0" rtlCol="0" anchor="ctr"/>
           <a:lstStyle/>
           <a:p>
-            <a:pPr indent="0" marL="0">
+            <a:pPr marL="0" indent="0">
               <a:buNone/>
             </a:pPr>
             <a:r>
@@ -6979,7 +6586,7 @@
           <a:bodyPr wrap="square" lIns="0" tIns="0" rIns="0" bIns="0" rtlCol="0" anchor="ctr"/>
           <a:lstStyle/>
           <a:p>
-            <a:pPr indent="0" marL="0">
+            <a:pPr marL="0" indent="0">
               <a:lnSpc>
                 <a:spcPts val="1700"/>
               </a:lnSpc>
@@ -7026,6 +6633,13 @@
             <a:prstDash val="solid"/>
           </a:ln>
         </p:spPr>
+        <p:txBody>
+          <a:bodyPr/>
+          <a:lstStyle/>
+          <a:p>
+            <a:endParaRPr lang="en-BE"/>
+          </a:p>
+        </p:txBody>
       </p:sp>
       <p:sp>
         <p:nvSpPr>
@@ -7048,7 +6662,7 @@
           <a:bodyPr wrap="square" lIns="0" tIns="0" rIns="0" bIns="0" rtlCol="0" anchor="ctr"/>
           <a:lstStyle/>
           <a:p>
-            <a:pPr indent="0" marL="0">
+            <a:pPr marL="0" indent="0">
               <a:buNone/>
             </a:pPr>
             <a:r>
@@ -7087,7 +6701,7 @@
           <a:bodyPr wrap="square" lIns="0" tIns="0" rIns="0" bIns="0" rtlCol="0" anchor="ctr"/>
           <a:lstStyle/>
           <a:p>
-            <a:pPr indent="0" marL="0">
+            <a:pPr marL="0" indent="0">
               <a:lnSpc>
                 <a:spcPts val="1700"/>
               </a:lnSpc>
@@ -7134,6 +6748,13 @@
             <a:prstDash val="solid"/>
           </a:ln>
         </p:spPr>
+        <p:txBody>
+          <a:bodyPr/>
+          <a:lstStyle/>
+          <a:p>
+            <a:endParaRPr lang="en-BE"/>
+          </a:p>
+        </p:txBody>
       </p:sp>
       <p:sp>
         <p:nvSpPr>
@@ -7156,7 +6777,7 @@
           <a:bodyPr wrap="square" lIns="0" tIns="0" rIns="0" bIns="0" rtlCol="0" anchor="ctr"/>
           <a:lstStyle/>
           <a:p>
-            <a:pPr indent="0" marL="0">
+            <a:pPr marL="0" indent="0">
               <a:buNone/>
             </a:pPr>
             <a:r>
@@ -7195,7 +6816,7 @@
           <a:bodyPr wrap="square" lIns="0" tIns="0" rIns="0" bIns="0" rtlCol="0" anchor="ctr"/>
           <a:lstStyle/>
           <a:p>
-            <a:pPr indent="0" marL="0">
+            <a:pPr marL="0" indent="0">
               <a:lnSpc>
                 <a:spcPts val="1700"/>
               </a:lnSpc>
@@ -7233,7 +6854,10 @@
             </a:avLst>
           </a:prstGeom>
           <a:solidFill>
-            <a:srgbClr val="14503F"/>
+            <a:schemeClr val="accent5">
+              <a:lumMod val="60000"/>
+              <a:lumOff val="40000"/>
+            </a:schemeClr>
           </a:solidFill>
           <a:ln w="12700">
             <a:solidFill>
@@ -7242,13 +6866,20 @@
             <a:prstDash val="solid"/>
           </a:ln>
           <a:effectLst>
-            <a:outerShdw sx="100000" sy="100000" kx="0" ky="0" algn="bl" rotWithShape="0" blurRad="177800" dist="25400" dir="5400000">
+            <a:outerShdw blurRad="177800" dist="25400" dir="5400000" algn="bl" rotWithShape="0">
               <a:srgbClr val="0A1622">
                 <a:alpha val="16000"/>
               </a:srgbClr>
             </a:outerShdw>
           </a:effectLst>
         </p:spPr>
+        <p:txBody>
+          <a:bodyPr/>
+          <a:lstStyle/>
+          <a:p>
+            <a:endParaRPr lang="en-BE"/>
+          </a:p>
+        </p:txBody>
       </p:sp>
       <p:sp>
         <p:nvSpPr>
@@ -7271,13 +6902,15 @@
           <a:bodyPr wrap="square" lIns="0" tIns="0" rIns="0" bIns="0" rtlCol="0" anchor="ctr"/>
           <a:lstStyle/>
           <a:p>
-            <a:pPr indent="0" marL="0">
+            <a:pPr marL="0" indent="0">
               <a:buNone/>
             </a:pPr>
             <a:r>
               <a:rPr lang="en-US" sz="1450" b="1" dirty="0">
                 <a:solidFill>
-                  <a:srgbClr val="2DD4BF"/>
+                  <a:schemeClr val="accent1">
+                    <a:lumMod val="50000"/>
+                  </a:schemeClr>
                 </a:solidFill>
                 <a:latin typeface="Calibri" pitchFamily="34" charset="0"/>
                 <a:ea typeface="Calibri" pitchFamily="34" charset="-122"/>
@@ -7285,7 +6918,13 @@
               </a:rPr>
               <a:t>Because the GPU never sees patient data, it does not need a compliance-grade host — so inference costs a fraction of a cent per report.</a:t>
             </a:r>
-            <a:endParaRPr lang="en-US" sz="1450" dirty="0"/>
+            <a:endParaRPr lang="en-US" sz="1450" dirty="0">
+              <a:solidFill>
+                <a:schemeClr val="accent1">
+                  <a:lumMod val="50000"/>
+                </a:schemeClr>
+              </a:solidFill>
+            </a:endParaRPr>
           </a:p>
         </p:txBody>
       </p:sp>
@@ -7305,6 +6944,7 @@
         <a:solidFill>
           <a:srgbClr val="F8FAFC"/>
         </a:solidFill>
+        <a:effectLst/>
       </p:bgPr>
     </p:bg>
     <p:spTree>
@@ -7342,11 +6982,11 @@
           <a:bodyPr wrap="square" lIns="0" tIns="0" rIns="0" bIns="0" rtlCol="0" anchor="ctr"/>
           <a:lstStyle/>
           <a:p>
-            <a:pPr indent="0" marL="0">
-              <a:buNone/>
-            </a:pPr>
-            <a:r>
-              <a:rPr lang="en-US" sz="1300" b="1" spc="200" kern="0" dirty="0">
+            <a:pPr marL="0" indent="0">
+              <a:buNone/>
+            </a:pPr>
+            <a:r>
+              <a:rPr lang="en-US" sz="1300" b="1" kern="0" spc="200" dirty="0">
                 <a:solidFill>
                   <a:srgbClr val="0F766E"/>
                 </a:solidFill>
@@ -7381,7 +7021,7 @@
           <a:bodyPr wrap="square" lIns="0" tIns="0" rIns="0" bIns="0" rtlCol="0" anchor="ctr"/>
           <a:lstStyle/>
           <a:p>
-            <a:pPr indent="0" marL="0">
+            <a:pPr marL="0" indent="0">
               <a:buNone/>
             </a:pPr>
             <a:r>
@@ -7425,13 +7065,20 @@
             <a:prstDash val="solid"/>
           </a:ln>
           <a:effectLst>
-            <a:outerShdw sx="100000" sy="100000" kx="0" ky="0" algn="bl" rotWithShape="0" blurRad="177800" dist="25400" dir="5400000">
+            <a:outerShdw blurRad="177800" dist="25400" dir="5400000" algn="bl" rotWithShape="0">
               <a:srgbClr val="0A1622">
                 <a:alpha val="16000"/>
               </a:srgbClr>
             </a:outerShdw>
           </a:effectLst>
         </p:spPr>
+        <p:txBody>
+          <a:bodyPr/>
+          <a:lstStyle/>
+          <a:p>
+            <a:endParaRPr lang="en-BE"/>
+          </a:p>
+        </p:txBody>
       </p:sp>
       <p:sp>
         <p:nvSpPr>
@@ -7454,7 +7101,7 @@
           <a:bodyPr wrap="square" lIns="0" tIns="0" rIns="0" bIns="0" rtlCol="0" anchor="ctr"/>
           <a:lstStyle/>
           <a:p>
-            <a:pPr indent="0" marL="0">
+            <a:pPr marL="0" indent="0">
               <a:buNone/>
             </a:pPr>
             <a:r>
@@ -7493,7 +7140,7 @@
           <a:bodyPr wrap="square" lIns="0" tIns="0" rIns="0" bIns="0" rtlCol="0" anchor="ctr"/>
           <a:lstStyle/>
           <a:p>
-            <a:pPr indent="0" marL="0">
+            <a:pPr marL="0" indent="0">
               <a:lnSpc>
                 <a:spcPts val="1500"/>
               </a:lnSpc>
@@ -7540,13 +7187,20 @@
             <a:prstDash val="solid"/>
           </a:ln>
           <a:effectLst>
-            <a:outerShdw sx="100000" sy="100000" kx="0" ky="0" algn="bl" rotWithShape="0" blurRad="177800" dist="25400" dir="5400000">
+            <a:outerShdw blurRad="177800" dist="25400" dir="5400000" algn="bl" rotWithShape="0">
               <a:srgbClr val="0A1622">
                 <a:alpha val="16000"/>
               </a:srgbClr>
             </a:outerShdw>
           </a:effectLst>
         </p:spPr>
+        <p:txBody>
+          <a:bodyPr/>
+          <a:lstStyle/>
+          <a:p>
+            <a:endParaRPr lang="en-BE"/>
+          </a:p>
+        </p:txBody>
       </p:sp>
       <p:sp>
         <p:nvSpPr>
@@ -7569,7 +7223,7 @@
           <a:bodyPr wrap="square" lIns="0" tIns="0" rIns="0" bIns="0" rtlCol="0" anchor="ctr"/>
           <a:lstStyle/>
           <a:p>
-            <a:pPr indent="0" marL="0">
+            <a:pPr marL="0" indent="0">
               <a:buNone/>
             </a:pPr>
             <a:r>
@@ -7608,7 +7262,7 @@
           <a:bodyPr wrap="square" lIns="0" tIns="0" rIns="0" bIns="0" rtlCol="0" anchor="ctr"/>
           <a:lstStyle/>
           <a:p>
-            <a:pPr indent="0" marL="0">
+            <a:pPr marL="0" indent="0">
               <a:lnSpc>
                 <a:spcPts val="1500"/>
               </a:lnSpc>
@@ -7655,13 +7309,20 @@
             <a:prstDash val="solid"/>
           </a:ln>
           <a:effectLst>
-            <a:outerShdw sx="100000" sy="100000" kx="0" ky="0" algn="bl" rotWithShape="0" blurRad="177800" dist="25400" dir="5400000">
+            <a:outerShdw blurRad="177800" dist="25400" dir="5400000" algn="bl" rotWithShape="0">
               <a:srgbClr val="0A1622">
                 <a:alpha val="16000"/>
               </a:srgbClr>
             </a:outerShdw>
           </a:effectLst>
         </p:spPr>
+        <p:txBody>
+          <a:bodyPr/>
+          <a:lstStyle/>
+          <a:p>
+            <a:endParaRPr lang="en-BE"/>
+          </a:p>
+        </p:txBody>
       </p:sp>
       <p:sp>
         <p:nvSpPr>
@@ -7684,7 +7345,7 @@
           <a:bodyPr wrap="square" lIns="0" tIns="0" rIns="0" bIns="0" rtlCol="0" anchor="ctr"/>
           <a:lstStyle/>
           <a:p>
-            <a:pPr indent="0" marL="0">
+            <a:pPr marL="0" indent="0">
               <a:buNone/>
             </a:pPr>
             <a:r>
@@ -7723,7 +7384,7 @@
           <a:bodyPr wrap="square" lIns="0" tIns="0" rIns="0" bIns="0" rtlCol="0" anchor="ctr"/>
           <a:lstStyle/>
           <a:p>
-            <a:pPr indent="0" marL="0">
+            <a:pPr marL="0" indent="0">
               <a:lnSpc>
                 <a:spcPts val="1500"/>
               </a:lnSpc>
@@ -7770,13 +7431,20 @@
             <a:prstDash val="solid"/>
           </a:ln>
           <a:effectLst>
-            <a:outerShdw sx="100000" sy="100000" kx="0" ky="0" algn="bl" rotWithShape="0" blurRad="177800" dist="25400" dir="5400000">
+            <a:outerShdw blurRad="177800" dist="25400" dir="5400000" algn="bl" rotWithShape="0">
               <a:srgbClr val="0A1622">
                 <a:alpha val="16000"/>
               </a:srgbClr>
             </a:outerShdw>
           </a:effectLst>
         </p:spPr>
+        <p:txBody>
+          <a:bodyPr/>
+          <a:lstStyle/>
+          <a:p>
+            <a:endParaRPr lang="en-BE"/>
+          </a:p>
+        </p:txBody>
       </p:sp>
       <p:sp>
         <p:nvSpPr>
@@ -7799,7 +7467,7 @@
           <a:bodyPr wrap="square" lIns="0" tIns="0" rIns="0" bIns="0" rtlCol="0" anchor="ctr"/>
           <a:lstStyle/>
           <a:p>
-            <a:pPr indent="0" marL="0">
+            <a:pPr marL="0" indent="0">
               <a:buNone/>
             </a:pPr>
             <a:r>
@@ -7838,7 +7506,7 @@
           <a:bodyPr wrap="square" lIns="0" tIns="0" rIns="0" bIns="0" rtlCol="0" anchor="ctr"/>
           <a:lstStyle/>
           <a:p>
-            <a:pPr indent="0" marL="0">
+            <a:pPr marL="0" indent="0">
               <a:lnSpc>
                 <a:spcPts val="1500"/>
               </a:lnSpc>
@@ -7885,13 +7553,20 @@
             <a:prstDash val="solid"/>
           </a:ln>
           <a:effectLst>
-            <a:outerShdw sx="100000" sy="100000" kx="0" ky="0" algn="bl" rotWithShape="0" blurRad="177800" dist="25400" dir="5400000">
+            <a:outerShdw blurRad="177800" dist="25400" dir="5400000" algn="bl" rotWithShape="0">
               <a:srgbClr val="0A1622">
                 <a:alpha val="16000"/>
               </a:srgbClr>
             </a:outerShdw>
           </a:effectLst>
         </p:spPr>
+        <p:txBody>
+          <a:bodyPr/>
+          <a:lstStyle/>
+          <a:p>
+            <a:endParaRPr lang="en-BE"/>
+          </a:p>
+        </p:txBody>
       </p:sp>
       <p:sp>
         <p:nvSpPr>
@@ -7914,7 +7589,7 @@
           <a:bodyPr wrap="square" lIns="0" tIns="0" rIns="0" bIns="0" rtlCol="0" anchor="ctr"/>
           <a:lstStyle/>
           <a:p>
-            <a:pPr indent="0" marL="0">
+            <a:pPr marL="0" indent="0">
               <a:buNone/>
             </a:pPr>
             <a:r>
@@ -7953,7 +7628,7 @@
           <a:bodyPr wrap="square" lIns="0" tIns="0" rIns="0" bIns="0" rtlCol="0" anchor="ctr"/>
           <a:lstStyle/>
           <a:p>
-            <a:pPr indent="0" marL="0">
+            <a:pPr marL="0" indent="0">
               <a:lnSpc>
                 <a:spcPts val="1700"/>
               </a:lnSpc>
@@ -7995,7 +7670,7 @@
           <a:bodyPr wrap="square" lIns="0" tIns="0" rIns="0" bIns="0" rtlCol="0" anchor="ctr"/>
           <a:lstStyle/>
           <a:p>
-            <a:pPr indent="0" marL="0">
+            <a:pPr marL="0" indent="0">
               <a:lnSpc>
                 <a:spcPts val="1600"/>
               </a:lnSpc>
@@ -8042,13 +7717,20 @@
             <a:prstDash val="solid"/>
           </a:ln>
           <a:effectLst>
-            <a:outerShdw sx="100000" sy="100000" kx="0" ky="0" algn="bl" rotWithShape="0" blurRad="177800" dist="25400" dir="5400000">
+            <a:outerShdw blurRad="177800" dist="25400" dir="5400000" algn="bl" rotWithShape="0">
               <a:srgbClr val="0A1622">
                 <a:alpha val="16000"/>
               </a:srgbClr>
             </a:outerShdw>
           </a:effectLst>
         </p:spPr>
+        <p:txBody>
+          <a:bodyPr/>
+          <a:lstStyle/>
+          <a:p>
+            <a:endParaRPr lang="en-BE"/>
+          </a:p>
+        </p:txBody>
       </p:sp>
       <p:sp>
         <p:nvSpPr>
@@ -8071,7 +7753,7 @@
           <a:bodyPr wrap="square" lIns="0" tIns="0" rIns="0" bIns="0" rtlCol="0" anchor="ctr"/>
           <a:lstStyle/>
           <a:p>
-            <a:pPr indent="0" marL="0">
+            <a:pPr marL="0" indent="0">
               <a:buNone/>
             </a:pPr>
             <a:r>
@@ -8110,7 +7792,7 @@
           <a:bodyPr wrap="square" lIns="0" tIns="0" rIns="0" bIns="0" rtlCol="0" anchor="ctr"/>
           <a:lstStyle/>
           <a:p>
-            <a:pPr indent="0" marL="0">
+            <a:pPr marL="0" indent="0">
               <a:buNone/>
             </a:pPr>
             <a:r>
@@ -8149,7 +7831,7 @@
           <a:bodyPr wrap="square" lIns="0" tIns="0" rIns="0" bIns="0" rtlCol="0" anchor="ctr"/>
           <a:lstStyle/>
           <a:p>
-            <a:pPr indent="0" marL="0">
+            <a:pPr marL="0" indent="0">
               <a:buNone/>
             </a:pPr>
             <a:r>
@@ -8188,7 +7870,7 @@
           <a:bodyPr wrap="square" lIns="0" tIns="0" rIns="0" bIns="0" rtlCol="0" anchor="ctr"/>
           <a:lstStyle/>
           <a:p>
-            <a:pPr indent="0" marL="0">
+            <a:pPr marL="0" indent="0">
               <a:buNone/>
             </a:pPr>
             <a:r>
@@ -8227,7 +7909,7 @@
           <a:bodyPr wrap="square" lIns="0" tIns="0" rIns="0" bIns="0" rtlCol="0" anchor="ctr"/>
           <a:lstStyle/>
           <a:p>
-            <a:pPr indent="0" marL="0">
+            <a:pPr marL="0" indent="0">
               <a:buNone/>
             </a:pPr>
             <a:r>
@@ -8266,7 +7948,7 @@
           <a:bodyPr wrap="square" lIns="0" tIns="0" rIns="0" bIns="0" rtlCol="0" anchor="ctr"/>
           <a:lstStyle/>
           <a:p>
-            <a:pPr indent="0" marL="0">
+            <a:pPr marL="0" indent="0">
               <a:buNone/>
             </a:pPr>
             <a:r>
@@ -8305,7 +7987,7 @@
           <a:bodyPr wrap="square" lIns="0" tIns="0" rIns="0" bIns="0" rtlCol="0" anchor="ctr"/>
           <a:lstStyle/>
           <a:p>
-            <a:pPr indent="0" marL="0">
+            <a:pPr marL="0" indent="0">
               <a:buNone/>
             </a:pPr>
             <a:r>
@@ -8344,7 +8026,7 @@
           <a:bodyPr wrap="square" lIns="0" tIns="0" rIns="0" bIns="0" rtlCol="0" anchor="ctr"/>
           <a:lstStyle/>
           <a:p>
-            <a:pPr indent="0" marL="0">
+            <a:pPr marL="0" indent="0">
               <a:buNone/>
             </a:pPr>
             <a:r>
@@ -8383,7 +8065,7 @@
           <a:bodyPr wrap="square" lIns="0" tIns="0" rIns="0" bIns="0" rtlCol="0" anchor="ctr"/>
           <a:lstStyle/>
           <a:p>
-            <a:pPr indent="0" marL="0">
+            <a:pPr marL="0" indent="0">
               <a:buNone/>
             </a:pPr>
             <a:r>
@@ -8417,6 +8099,7 @@
         <a:solidFill>
           <a:srgbClr val="F8FAFC"/>
         </a:solidFill>
+        <a:effectLst/>
       </p:bgPr>
     </p:bg>
     <p:spTree>
@@ -8454,11 +8137,11 @@
           <a:bodyPr wrap="square" lIns="0" tIns="0" rIns="0" bIns="0" rtlCol="0" anchor="ctr"/>
           <a:lstStyle/>
           <a:p>
-            <a:pPr indent="0" marL="0">
-              <a:buNone/>
-            </a:pPr>
-            <a:r>
-              <a:rPr lang="en-US" sz="1300" b="1" spc="200" kern="0" dirty="0">
+            <a:pPr marL="0" indent="0">
+              <a:buNone/>
+            </a:pPr>
+            <a:r>
+              <a:rPr lang="en-US" sz="1300" b="1" kern="0" spc="200" dirty="0">
                 <a:solidFill>
                   <a:srgbClr val="0F766E"/>
                 </a:solidFill>
@@ -8493,7 +8176,7 @@
           <a:bodyPr wrap="square" lIns="0" tIns="0" rIns="0" bIns="0" rtlCol="0" anchor="ctr"/>
           <a:lstStyle/>
           <a:p>
-            <a:pPr indent="0" marL="0">
+            <a:pPr marL="0" indent="0">
               <a:buNone/>
             </a:pPr>
             <a:r>
@@ -8537,13 +8220,20 @@
             <a:prstDash val="solid"/>
           </a:ln>
           <a:effectLst>
-            <a:outerShdw sx="100000" sy="100000" kx="0" ky="0" algn="bl" rotWithShape="0" blurRad="177800" dist="25400" dir="5400000">
+            <a:outerShdw blurRad="177800" dist="25400" dir="5400000" algn="bl" rotWithShape="0">
               <a:srgbClr val="0A1622">
                 <a:alpha val="16000"/>
               </a:srgbClr>
             </a:outerShdw>
           </a:effectLst>
         </p:spPr>
+        <p:txBody>
+          <a:bodyPr/>
+          <a:lstStyle/>
+          <a:p>
+            <a:endParaRPr lang="en-BE"/>
+          </a:p>
+        </p:txBody>
       </p:sp>
       <p:sp>
         <p:nvSpPr>
@@ -8566,7 +8256,7 @@
           <a:bodyPr wrap="square" lIns="0" tIns="0" rIns="0" bIns="0" rtlCol="0" anchor="ctr"/>
           <a:lstStyle/>
           <a:p>
-            <a:pPr indent="0" marL="0">
+            <a:pPr marL="0" indent="0">
               <a:buNone/>
             </a:pPr>
             <a:r>
@@ -8605,7 +8295,7 @@
           <a:bodyPr wrap="square" lIns="0" tIns="0" rIns="0" bIns="0" rtlCol="0" anchor="ctr"/>
           <a:lstStyle/>
           <a:p>
-            <a:pPr indent="0" marL="0">
+            <a:pPr marL="0" indent="0">
               <a:buNone/>
             </a:pPr>
             <a:r>
@@ -8644,7 +8334,7 @@
           <a:bodyPr wrap="square" lIns="0" tIns="0" rIns="0" bIns="0" rtlCol="0" anchor="ctr"/>
           <a:lstStyle/>
           <a:p>
-            <a:pPr indent="0" marL="0">
+            <a:pPr marL="0" indent="0">
               <a:lnSpc>
                 <a:spcPts val="1400"/>
               </a:lnSpc>
@@ -8664,7 +8354,7 @@
             <a:endParaRPr lang="en-US" sz="1050" dirty="0"/>
           </a:p>
           <a:p>
-            <a:pPr indent="0" marL="0">
+            <a:pPr marL="0" indent="0">
               <a:lnSpc>
                 <a:spcPts val="1400"/>
               </a:lnSpc>
@@ -8711,13 +8401,20 @@
             <a:prstDash val="solid"/>
           </a:ln>
           <a:effectLst>
-            <a:outerShdw sx="100000" sy="100000" kx="0" ky="0" algn="bl" rotWithShape="0" blurRad="177800" dist="25400" dir="5400000">
+            <a:outerShdw blurRad="177800" dist="25400" dir="5400000" algn="bl" rotWithShape="0">
               <a:srgbClr val="0A1622">
                 <a:alpha val="16000"/>
               </a:srgbClr>
             </a:outerShdw>
           </a:effectLst>
         </p:spPr>
+        <p:txBody>
+          <a:bodyPr/>
+          <a:lstStyle/>
+          <a:p>
+            <a:endParaRPr lang="en-BE"/>
+          </a:p>
+        </p:txBody>
       </p:sp>
       <p:sp>
         <p:nvSpPr>
@@ -8740,7 +8437,7 @@
           <a:bodyPr wrap="square" lIns="0" tIns="0" rIns="0" bIns="0" rtlCol="0" anchor="ctr"/>
           <a:lstStyle/>
           <a:p>
-            <a:pPr indent="0" marL="0">
+            <a:pPr marL="0" indent="0">
               <a:buNone/>
             </a:pPr>
             <a:r>
@@ -8779,7 +8476,7 @@
           <a:bodyPr wrap="square" lIns="0" tIns="0" rIns="0" bIns="0" rtlCol="0" anchor="ctr"/>
           <a:lstStyle/>
           <a:p>
-            <a:pPr indent="0" marL="0">
+            <a:pPr marL="0" indent="0">
               <a:buNone/>
             </a:pPr>
             <a:r>
@@ -8818,7 +8515,7 @@
           <a:bodyPr wrap="square" lIns="0" tIns="0" rIns="0" bIns="0" rtlCol="0" anchor="ctr"/>
           <a:lstStyle/>
           <a:p>
-            <a:pPr indent="0" marL="0">
+            <a:pPr marL="0" indent="0">
               <a:lnSpc>
                 <a:spcPts val="1400"/>
               </a:lnSpc>
@@ -8838,7 +8535,7 @@
             <a:endParaRPr lang="en-US" sz="1050" dirty="0"/>
           </a:p>
           <a:p>
-            <a:pPr indent="0" marL="0">
+            <a:pPr marL="0" indent="0">
               <a:lnSpc>
                 <a:spcPts val="1400"/>
               </a:lnSpc>
@@ -8885,13 +8582,20 @@
             <a:prstDash val="solid"/>
           </a:ln>
           <a:effectLst>
-            <a:outerShdw sx="100000" sy="100000" kx="0" ky="0" algn="bl" rotWithShape="0" blurRad="177800" dist="25400" dir="5400000">
+            <a:outerShdw blurRad="177800" dist="25400" dir="5400000" algn="bl" rotWithShape="0">
               <a:srgbClr val="0A1622">
                 <a:alpha val="16000"/>
               </a:srgbClr>
             </a:outerShdw>
           </a:effectLst>
         </p:spPr>
+        <p:txBody>
+          <a:bodyPr/>
+          <a:lstStyle/>
+          <a:p>
+            <a:endParaRPr lang="en-BE"/>
+          </a:p>
+        </p:txBody>
       </p:sp>
       <p:sp>
         <p:nvSpPr>
@@ -8914,7 +8618,7 @@
           <a:bodyPr wrap="square" lIns="0" tIns="0" rIns="0" bIns="0" rtlCol="0" anchor="ctr"/>
           <a:lstStyle/>
           <a:p>
-            <a:pPr indent="0" marL="0">
+            <a:pPr marL="0" indent="0">
               <a:buNone/>
             </a:pPr>
             <a:r>
@@ -8953,7 +8657,7 @@
           <a:bodyPr wrap="square" lIns="0" tIns="0" rIns="0" bIns="0" rtlCol="0" anchor="ctr"/>
           <a:lstStyle/>
           <a:p>
-            <a:pPr indent="0" marL="0">
+            <a:pPr marL="0" indent="0">
               <a:buNone/>
             </a:pPr>
             <a:r>
@@ -8992,7 +8696,7 @@
           <a:bodyPr wrap="square" lIns="0" tIns="0" rIns="0" bIns="0" rtlCol="0" anchor="ctr"/>
           <a:lstStyle/>
           <a:p>
-            <a:pPr indent="0" marL="0">
+            <a:pPr marL="0" indent="0">
               <a:lnSpc>
                 <a:spcPts val="1400"/>
               </a:lnSpc>
@@ -9012,7 +8716,7 @@
             <a:endParaRPr lang="en-US" sz="1050" dirty="0"/>
           </a:p>
           <a:p>
-            <a:pPr indent="0" marL="0">
+            <a:pPr marL="0" indent="0">
               <a:lnSpc>
                 <a:spcPts val="1400"/>
               </a:lnSpc>
@@ -9059,13 +8763,20 @@
             <a:prstDash val="solid"/>
           </a:ln>
           <a:effectLst>
-            <a:outerShdw sx="100000" sy="100000" kx="0" ky="0" algn="bl" rotWithShape="0" blurRad="177800" dist="25400" dir="5400000">
+            <a:outerShdw blurRad="177800" dist="25400" dir="5400000" algn="bl" rotWithShape="0">
               <a:srgbClr val="0A1622">
                 <a:alpha val="16000"/>
               </a:srgbClr>
             </a:outerShdw>
           </a:effectLst>
         </p:spPr>
+        <p:txBody>
+          <a:bodyPr/>
+          <a:lstStyle/>
+          <a:p>
+            <a:endParaRPr lang="en-BE"/>
+          </a:p>
+        </p:txBody>
       </p:sp>
       <p:sp>
         <p:nvSpPr>
@@ -9088,7 +8799,7 @@
           <a:bodyPr wrap="square" lIns="0" tIns="0" rIns="0" bIns="0" rtlCol="0" anchor="ctr"/>
           <a:lstStyle/>
           <a:p>
-            <a:pPr indent="0" marL="0">
+            <a:pPr marL="0" indent="0">
               <a:buNone/>
             </a:pPr>
             <a:r>
@@ -9127,7 +8838,7 @@
           <a:bodyPr wrap="square" lIns="0" tIns="0" rIns="0" bIns="0" rtlCol="0" anchor="ctr"/>
           <a:lstStyle/>
           <a:p>
-            <a:pPr indent="0" marL="0">
+            <a:pPr marL="0" indent="0">
               <a:buNone/>
             </a:pPr>
             <a:r>
@@ -9166,7 +8877,7 @@
           <a:bodyPr wrap="square" lIns="0" tIns="0" rIns="0" bIns="0" rtlCol="0" anchor="ctr"/>
           <a:lstStyle/>
           <a:p>
-            <a:pPr indent="0" marL="0">
+            <a:pPr marL="0" indent="0">
               <a:lnSpc>
                 <a:spcPts val="1400"/>
               </a:lnSpc>
@@ -9186,7 +8897,7 @@
             <a:endParaRPr lang="en-US" sz="1050" dirty="0"/>
           </a:p>
           <a:p>
-            <a:pPr indent="0" marL="0">
+            <a:pPr marL="0" indent="0">
               <a:lnSpc>
                 <a:spcPts val="1400"/>
               </a:lnSpc>
@@ -9233,6 +8944,13 @@
             <a:prstDash val="solid"/>
           </a:ln>
         </p:spPr>
+        <p:txBody>
+          <a:bodyPr/>
+          <a:lstStyle/>
+          <a:p>
+            <a:endParaRPr lang="en-BE"/>
+          </a:p>
+        </p:txBody>
       </p:sp>
       <p:sp>
         <p:nvSpPr>
@@ -9255,7 +8973,7 @@
           <a:bodyPr wrap="square" lIns="0" tIns="0" rIns="0" bIns="0" rtlCol="0" anchor="ctr"/>
           <a:lstStyle/>
           <a:p>
-            <a:pPr indent="0" marL="0">
+            <a:pPr marL="0" indent="0">
               <a:buNone/>
             </a:pPr>
             <a:r>
@@ -9294,7 +9012,7 @@
           <a:bodyPr wrap="square" lIns="0" tIns="0" rIns="0" bIns="0" rtlCol="0" anchor="ctr"/>
           <a:lstStyle/>
           <a:p>
-            <a:pPr indent="0" marL="0">
+            <a:pPr marL="0" indent="0">
               <a:buNone/>
             </a:pPr>
             <a:r>
@@ -9333,7 +9051,7 @@
           <a:bodyPr wrap="square" lIns="0" tIns="0" rIns="0" bIns="0" rtlCol="0" anchor="ctr"/>
           <a:lstStyle/>
           <a:p>
-            <a:pPr indent="0" marL="0">
+            <a:pPr marL="0" indent="0">
               <a:buNone/>
             </a:pPr>
             <a:r>
@@ -9372,7 +9090,7 @@
           <a:bodyPr wrap="square" lIns="0" tIns="0" rIns="0" bIns="0" rtlCol="0" anchor="ctr"/>
           <a:lstStyle/>
           <a:p>
-            <a:pPr algn="r" indent="0" marL="0">
+            <a:pPr marL="0" indent="0" algn="r">
               <a:buNone/>
             </a:pPr>
             <a:r>
@@ -9416,6 +9134,13 @@
             <a:prstDash val="solid"/>
           </a:ln>
         </p:spPr>
+        <p:txBody>
+          <a:bodyPr/>
+          <a:lstStyle/>
+          <a:p>
+            <a:endParaRPr lang="en-BE"/>
+          </a:p>
+        </p:txBody>
       </p:sp>
       <p:sp>
         <p:nvSpPr>
@@ -9438,7 +9163,7 @@
           <a:bodyPr wrap="square" lIns="0" tIns="0" rIns="0" bIns="0" rtlCol="0" anchor="ctr"/>
           <a:lstStyle/>
           <a:p>
-            <a:pPr indent="0" marL="0">
+            <a:pPr marL="0" indent="0">
               <a:buNone/>
             </a:pPr>
             <a:r>
@@ -9477,7 +9202,7 @@
           <a:bodyPr wrap="square" lIns="0" tIns="0" rIns="0" bIns="0" rtlCol="0" anchor="ctr"/>
           <a:lstStyle/>
           <a:p>
-            <a:pPr indent="0" marL="0">
+            <a:pPr marL="0" indent="0">
               <a:buNone/>
             </a:pPr>
             <a:r>
@@ -9516,7 +9241,7 @@
           <a:bodyPr wrap="square" lIns="0" tIns="0" rIns="0" bIns="0" rtlCol="0" anchor="ctr"/>
           <a:lstStyle/>
           <a:p>
-            <a:pPr indent="0" marL="0">
+            <a:pPr marL="0" indent="0">
               <a:buNone/>
             </a:pPr>
             <a:r>
@@ -9555,7 +9280,7 @@
           <a:bodyPr wrap="square" lIns="0" tIns="0" rIns="0" bIns="0" rtlCol="0" anchor="ctr"/>
           <a:lstStyle/>
           <a:p>
-            <a:pPr algn="r" indent="0" marL="0">
+            <a:pPr marL="0" indent="0" algn="r">
               <a:buNone/>
             </a:pPr>
             <a:r>
@@ -9599,6 +9324,13 @@
             <a:prstDash val="solid"/>
           </a:ln>
         </p:spPr>
+        <p:txBody>
+          <a:bodyPr/>
+          <a:lstStyle/>
+          <a:p>
+            <a:endParaRPr lang="en-BE"/>
+          </a:p>
+        </p:txBody>
       </p:sp>
       <p:sp>
         <p:nvSpPr>
@@ -9621,7 +9353,7 @@
           <a:bodyPr wrap="square" lIns="0" tIns="0" rIns="0" bIns="0" rtlCol="0" anchor="ctr"/>
           <a:lstStyle/>
           <a:p>
-            <a:pPr indent="0" marL="0">
+            <a:pPr marL="0" indent="0">
               <a:buNone/>
             </a:pPr>
             <a:r>
@@ -9660,7 +9392,7 @@
           <a:bodyPr wrap="square" lIns="0" tIns="0" rIns="0" bIns="0" rtlCol="0" anchor="ctr"/>
           <a:lstStyle/>
           <a:p>
-            <a:pPr indent="0" marL="0">
+            <a:pPr marL="0" indent="0">
               <a:buNone/>
             </a:pPr>
             <a:r>
@@ -9699,7 +9431,7 @@
           <a:bodyPr wrap="square" lIns="0" tIns="0" rIns="0" bIns="0" rtlCol="0" anchor="ctr"/>
           <a:lstStyle/>
           <a:p>
-            <a:pPr indent="0" marL="0">
+            <a:pPr marL="0" indent="0">
               <a:buNone/>
             </a:pPr>
             <a:r>
@@ -9738,7 +9470,7 @@
           <a:bodyPr wrap="square" lIns="0" tIns="0" rIns="0" bIns="0" rtlCol="0" anchor="ctr"/>
           <a:lstStyle/>
           <a:p>
-            <a:pPr algn="r" indent="0" marL="0">
+            <a:pPr marL="0" indent="0" algn="r">
               <a:buNone/>
             </a:pPr>
             <a:r>
@@ -10057,4 +9789,319 @@
     </a:ext>
   </a:extLst>
 </a:theme>
+</file>
+
+<file path=ppt/theme/theme2.xml><?xml version="1.0" encoding="utf-8"?>
+<a:theme xmlns:a="http://schemas.openxmlformats.org/drawingml/2006/main" name="Office Theme">
+  <a:themeElements>
+    <a:clrScheme name="Office">
+      <a:dk1>
+        <a:sysClr val="windowText" lastClr="000000"/>
+      </a:dk1>
+      <a:lt1>
+        <a:sysClr val="window" lastClr="FFFFFF"/>
+      </a:lt1>
+      <a:dk2>
+        <a:srgbClr val="0E2841"/>
+      </a:dk2>
+      <a:lt2>
+        <a:srgbClr val="E8E8E8"/>
+      </a:lt2>
+      <a:accent1>
+        <a:srgbClr val="156082"/>
+      </a:accent1>
+      <a:accent2>
+        <a:srgbClr val="E97132"/>
+      </a:accent2>
+      <a:accent3>
+        <a:srgbClr val="196B24"/>
+      </a:accent3>
+      <a:accent4>
+        <a:srgbClr val="0F9ED5"/>
+      </a:accent4>
+      <a:accent5>
+        <a:srgbClr val="A02B93"/>
+      </a:accent5>
+      <a:accent6>
+        <a:srgbClr val="4EA72E"/>
+      </a:accent6>
+      <a:hlink>
+        <a:srgbClr val="467886"/>
+      </a:hlink>
+      <a:folHlink>
+        <a:srgbClr val="96607D"/>
+      </a:folHlink>
+    </a:clrScheme>
+    <a:fontScheme name="Office">
+      <a:majorFont>
+        <a:latin typeface="Aptos Display" panose="02110004020202020204"/>
+        <a:ea typeface=""/>
+        <a:cs typeface=""/>
+        <a:font script="Jpan" typeface="游ゴシック Light"/>
+        <a:font script="Hang" typeface="맑은 고딕"/>
+        <a:font script="Hans" typeface="等线 Light"/>
+        <a:font script="Hant" typeface="新細明體"/>
+        <a:font script="Arab" typeface="Times New Roman"/>
+        <a:font script="Hebr" typeface="Times New Roman"/>
+        <a:font script="Thai" typeface="Angsana New"/>
+        <a:font script="Ethi" typeface="Nyala"/>
+        <a:font script="Beng" typeface="Vrinda"/>
+        <a:font script="Gujr" typeface="Shruti"/>
+        <a:font script="Khmr" typeface="MoolBoran"/>
+        <a:font script="Knda" typeface="Tunga"/>
+        <a:font script="Guru" typeface="Raavi"/>
+        <a:font script="Cans" typeface="Euphemia"/>
+        <a:font script="Cher" typeface="Plantagenet Cherokee"/>
+        <a:font script="Yiii" typeface="Microsoft Yi Baiti"/>
+        <a:font script="Tibt" typeface="Microsoft Himalaya"/>
+        <a:font script="Thaa" typeface="MV Boli"/>
+        <a:font script="Deva" typeface="Mangal"/>
+        <a:font script="Telu" typeface="Gautami"/>
+        <a:font script="Taml" typeface="Latha"/>
+        <a:font script="Syrc" typeface="Estrangelo Edessa"/>
+        <a:font script="Orya" typeface="Kalinga"/>
+        <a:font script="Mlym" typeface="Kartika"/>
+        <a:font script="Laoo" typeface="DokChampa"/>
+        <a:font script="Sinh" typeface="Iskoola Pota"/>
+        <a:font script="Mong" typeface="Mongolian Baiti"/>
+        <a:font script="Viet" typeface="Times New Roman"/>
+        <a:font script="Uigh" typeface="Microsoft Uighur"/>
+        <a:font script="Geor" typeface="Sylfaen"/>
+        <a:font script="Armn" typeface="Arial"/>
+        <a:font script="Bugi" typeface="Leelawadee UI"/>
+        <a:font script="Bopo" typeface="Microsoft JhengHei"/>
+        <a:font script="Java" typeface="Javanese Text"/>
+        <a:font script="Lisu" typeface="Segoe UI"/>
+        <a:font script="Mymr" typeface="Myanmar Text"/>
+        <a:font script="Nkoo" typeface="Ebrima"/>
+        <a:font script="Olck" typeface="Nirmala UI"/>
+        <a:font script="Osma" typeface="Ebrima"/>
+        <a:font script="Phag" typeface="Phagspa"/>
+        <a:font script="Syrn" typeface="Estrangelo Edessa"/>
+        <a:font script="Syrj" typeface="Estrangelo Edessa"/>
+        <a:font script="Syre" typeface="Estrangelo Edessa"/>
+        <a:font script="Sora" typeface="Nirmala UI"/>
+        <a:font script="Tale" typeface="Microsoft Tai Le"/>
+        <a:font script="Talu" typeface="Microsoft New Tai Lue"/>
+        <a:font script="Tfng" typeface="Ebrima"/>
+      </a:majorFont>
+      <a:minorFont>
+        <a:latin typeface="Aptos" panose="02110004020202020204"/>
+        <a:ea typeface=""/>
+        <a:cs typeface=""/>
+        <a:font script="Jpan" typeface="游ゴシック"/>
+        <a:font script="Hang" typeface="맑은 고딕"/>
+        <a:font script="Hans" typeface="等线"/>
+        <a:font script="Hant" typeface="新細明體"/>
+        <a:font script="Arab" typeface="Arial"/>
+        <a:font script="Hebr" typeface="Arial"/>
+        <a:font script="Thai" typeface="Cordia New"/>
+        <a:font script="Ethi" typeface="Nyala"/>
+        <a:font script="Beng" typeface="Vrinda"/>
+        <a:font script="Gujr" typeface="Shruti"/>
+        <a:font script="Khmr" typeface="DaunPenh"/>
+        <a:font script="Knda" typeface="Tunga"/>
+        <a:font script="Guru" typeface="Raavi"/>
+        <a:font script="Cans" typeface="Euphemia"/>
+        <a:font script="Cher" typeface="Plantagenet Cherokee"/>
+        <a:font script="Yiii" typeface="Microsoft Yi Baiti"/>
+        <a:font script="Tibt" typeface="Microsoft Himalaya"/>
+        <a:font script="Thaa" typeface="MV Boli"/>
+        <a:font script="Deva" typeface="Mangal"/>
+        <a:font script="Telu" typeface="Gautami"/>
+        <a:font script="Taml" typeface="Latha"/>
+        <a:font script="Syrc" typeface="Estrangelo Edessa"/>
+        <a:font script="Orya" typeface="Kalinga"/>
+        <a:font script="Mlym" typeface="Kartika"/>
+        <a:font script="Laoo" typeface="DokChampa"/>
+        <a:font script="Sinh" typeface="Iskoola Pota"/>
+        <a:font script="Mong" typeface="Mongolian Baiti"/>
+        <a:font script="Viet" typeface="Arial"/>
+        <a:font script="Uigh" typeface="Microsoft Uighur"/>
+        <a:font script="Geor" typeface="Sylfaen"/>
+        <a:font script="Armn" typeface="Arial"/>
+        <a:font script="Bugi" typeface="Leelawadee UI"/>
+        <a:font script="Bopo" typeface="Microsoft JhengHei"/>
+        <a:font script="Java" typeface="Javanese Text"/>
+        <a:font script="Lisu" typeface="Segoe UI"/>
+        <a:font script="Mymr" typeface="Myanmar Text"/>
+        <a:font script="Nkoo" typeface="Ebrima"/>
+        <a:font script="Olck" typeface="Nirmala UI"/>
+        <a:font script="Osma" typeface="Ebrima"/>
+        <a:font script="Phag" typeface="Phagspa"/>
+        <a:font script="Syrn" typeface="Estrangelo Edessa"/>
+        <a:font script="Syrj" typeface="Estrangelo Edessa"/>
+        <a:font script="Syre" typeface="Estrangelo Edessa"/>
+        <a:font script="Sora" typeface="Nirmala UI"/>
+        <a:font script="Tale" typeface="Microsoft Tai Le"/>
+        <a:font script="Talu" typeface="Microsoft New Tai Lue"/>
+        <a:font script="Tfng" typeface="Ebrima"/>
+      </a:minorFont>
+    </a:fontScheme>
+    <a:fmtScheme name="Office">
+      <a:fillStyleLst>
+        <a:solidFill>
+          <a:schemeClr val="phClr"/>
+        </a:solidFill>
+        <a:gradFill rotWithShape="1">
+          <a:gsLst>
+            <a:gs pos="0">
+              <a:schemeClr val="phClr">
+                <a:lumMod val="110000"/>
+                <a:satMod val="105000"/>
+                <a:tint val="67000"/>
+              </a:schemeClr>
+            </a:gs>
+            <a:gs pos="50000">
+              <a:schemeClr val="phClr">
+                <a:lumMod val="105000"/>
+                <a:satMod val="103000"/>
+                <a:tint val="73000"/>
+              </a:schemeClr>
+            </a:gs>
+            <a:gs pos="100000">
+              <a:schemeClr val="phClr">
+                <a:lumMod val="105000"/>
+                <a:satMod val="109000"/>
+                <a:tint val="81000"/>
+              </a:schemeClr>
+            </a:gs>
+          </a:gsLst>
+          <a:lin ang="5400000" scaled="0"/>
+        </a:gradFill>
+        <a:gradFill rotWithShape="1">
+          <a:gsLst>
+            <a:gs pos="0">
+              <a:schemeClr val="phClr">
+                <a:satMod val="103000"/>
+                <a:lumMod val="102000"/>
+                <a:tint val="94000"/>
+              </a:schemeClr>
+            </a:gs>
+            <a:gs pos="50000">
+              <a:schemeClr val="phClr">
+                <a:satMod val="110000"/>
+                <a:lumMod val="100000"/>
+                <a:shade val="100000"/>
+              </a:schemeClr>
+            </a:gs>
+            <a:gs pos="100000">
+              <a:schemeClr val="phClr">
+                <a:lumMod val="99000"/>
+                <a:satMod val="120000"/>
+                <a:shade val="78000"/>
+              </a:schemeClr>
+            </a:gs>
+          </a:gsLst>
+          <a:lin ang="5400000" scaled="0"/>
+        </a:gradFill>
+      </a:fillStyleLst>
+      <a:lnStyleLst>
+        <a:ln w="12700" cap="flat" cmpd="sng" algn="ctr">
+          <a:solidFill>
+            <a:schemeClr val="phClr"/>
+          </a:solidFill>
+          <a:prstDash val="solid"/>
+          <a:miter lim="800000"/>
+        </a:ln>
+        <a:ln w="19050" cap="flat" cmpd="sng" algn="ctr">
+          <a:solidFill>
+            <a:schemeClr val="phClr"/>
+          </a:solidFill>
+          <a:prstDash val="solid"/>
+          <a:miter lim="800000"/>
+        </a:ln>
+        <a:ln w="25400" cap="flat" cmpd="sng" algn="ctr">
+          <a:solidFill>
+            <a:schemeClr val="phClr"/>
+          </a:solidFill>
+          <a:prstDash val="solid"/>
+          <a:miter lim="800000"/>
+        </a:ln>
+      </a:lnStyleLst>
+      <a:effectStyleLst>
+        <a:effectStyle>
+          <a:effectLst/>
+        </a:effectStyle>
+        <a:effectStyle>
+          <a:effectLst/>
+        </a:effectStyle>
+        <a:effectStyle>
+          <a:effectLst>
+            <a:outerShdw blurRad="57150" dist="19050" dir="5400000" algn="ctr" rotWithShape="0">
+              <a:srgbClr val="000000">
+                <a:alpha val="63000"/>
+              </a:srgbClr>
+            </a:outerShdw>
+          </a:effectLst>
+        </a:effectStyle>
+      </a:effectStyleLst>
+      <a:bgFillStyleLst>
+        <a:solidFill>
+          <a:schemeClr val="phClr"/>
+        </a:solidFill>
+        <a:solidFill>
+          <a:schemeClr val="phClr">
+            <a:tint val="95000"/>
+            <a:satMod val="170000"/>
+          </a:schemeClr>
+        </a:solidFill>
+        <a:gradFill rotWithShape="1">
+          <a:gsLst>
+            <a:gs pos="0">
+              <a:schemeClr val="phClr">
+                <a:tint val="93000"/>
+                <a:satMod val="150000"/>
+                <a:shade val="98000"/>
+                <a:lumMod val="102000"/>
+              </a:schemeClr>
+            </a:gs>
+            <a:gs pos="50000">
+              <a:schemeClr val="phClr">
+                <a:tint val="98000"/>
+                <a:satMod val="130000"/>
+                <a:shade val="90000"/>
+                <a:lumMod val="103000"/>
+              </a:schemeClr>
+            </a:gs>
+            <a:gs pos="100000">
+              <a:schemeClr val="phClr">
+                <a:shade val="63000"/>
+                <a:satMod val="120000"/>
+              </a:schemeClr>
+            </a:gs>
+          </a:gsLst>
+          <a:lin ang="5400000" scaled="0"/>
+        </a:gradFill>
+      </a:bgFillStyleLst>
+    </a:fmtScheme>
+  </a:themeElements>
+  <a:objectDefaults>
+    <a:lnDef>
+      <a:spPr/>
+      <a:bodyPr/>
+      <a:lstStyle/>
+      <a:style>
+        <a:lnRef idx="2">
+          <a:schemeClr val="accent1"/>
+        </a:lnRef>
+        <a:fillRef idx="0">
+          <a:schemeClr val="accent1"/>
+        </a:fillRef>
+        <a:effectRef idx="1">
+          <a:schemeClr val="accent1"/>
+        </a:effectRef>
+        <a:fontRef idx="minor">
+          <a:schemeClr val="tx1"/>
+        </a:fontRef>
+      </a:style>
+    </a:lnDef>
+  </a:objectDefaults>
+  <a:extraClrSchemeLst/>
+  <a:extLst>
+    <a:ext uri="{05A4C25C-085E-4340-85A3-A5531E510DB2}">
+      <thm15:themeFamily xmlns:thm15="http://schemas.microsoft.com/office/thememl/2012/main" name="Office Theme" id="{2E142A2C-CD16-42D6-873A-C26D2A0506FA}" vid="{1BDDFF52-6CD6-40A5-AB3C-68EB2F1E4D0A}"/>
+    </a:ext>
+  </a:extLst>
+</a:theme>
 </file>
</xml_diff>